<commit_message>
Add PED calculation warm-up to Lesson 4
Insert a formula-refresher step and a 3-scenario interactive practice
step (restring service, limited-edition paddle, generic minifigure)
right after the quick fixes and before the revenue content, so PED
gets a warm-up rep before extending into total revenue. Mirrored the
same section into the teaching script and the pptx backup, renumbering
subsequent slides/steps accordingly.
</commit_message>
<xml_diff>
--- a/courses/tom-economics/lessons/lesson-04/slides.pptx
+++ b/courses/tom-economics/lessons/lesson-04/slides.pptx
@@ -21,9 +21,13 @@
     <p:sldId id="269" r:id="rId15"/>
     <p:sldId id="270" r:id="rId16"/>
     <p:sldId id="271" r:id="rId17"/>
+    <p:sldId id="272" r:id="rId18"/>
+    <p:sldId id="273" r:id="rId19"/>
+    <p:sldId id="274" r:id="rId20"/>
+    <p:sldId id="275" r:id="rId21"/>
   </p:sldIdLst>
   <p:notesMasterIdLst>
-    <p:notesMasterId r:id="rId18"/>
+    <p:notesMasterId r:id="rId22"/>
   </p:notesMasterIdLst>
   <p:sldSz cx="12192000" cy="6858000"/>
   <p:notesSz cx="6858000" cy="12192000"/>
@@ -1175,6 +1179,270 @@
 </p:notes>
 </file>
 
+<file path=ppt/notesSlides/notesSlide17.xml><?xml version="1.0" encoding="utf-8"?>
+<p:notes xmlns:a="http://schemas.openxmlformats.org/drawingml/2006/main" xmlns:r="http://schemas.openxmlformats.org/officeDocument/2006/relationships" xmlns:p="http://schemas.openxmlformats.org/presentationml/2006/main">
+  <p:cSld>
+    <p:spTree>
+      <p:nvGrpSpPr>
+        <p:cNvPr id="1" name=""/>
+        <p:cNvGrpSpPr/>
+        <p:nvPr/>
+      </p:nvGrpSpPr>
+      <p:grpSpPr>
+        <a:xfrm>
+          <a:off x="0" y="0"/>
+          <a:ext cx="0" cy="0"/>
+          <a:chOff x="0" y="0"/>
+          <a:chExt cx="0" cy="0"/>
+        </a:xfrm>
+      </p:grpSpPr>
+      <p:sp>
+        <p:nvSpPr>
+          <p:cNvPr id="2" name="Slide Image Placeholder 1"/>
+          <p:cNvSpPr>
+            <a:spLocks noGrp="1" noRot="1" noChangeAspect="1"/>
+          </p:cNvSpPr>
+          <p:nvPr>
+            <p:ph type="sldImg"/>
+          </p:nvPr>
+        </p:nvSpPr>
+        <p:spPr/>
+      </p:sp>
+      <p:sp>
+        <p:nvSpPr>
+          <p:cNvPr id="3" name="Notes Placeholder 2"/>
+          <p:cNvSpPr>
+            <a:spLocks noGrp="1"/>
+          </p:cNvSpPr>
+          <p:nvPr>
+            <p:ph type="body" idx="1"/>
+          </p:nvPr>
+        </p:nvSpPr>
+        <p:spPr/>
+        <p:txBody>
+          <a:bodyPr/>
+          <a:lstStyle/>
+          <a:p>
+            <a:r>
+              <a:rPr lang="en-US" dirty="0"/>
+              <a:t/>
+            </a:r>
+            <a:endParaRPr lang="en-US" dirty="0"/>
+          </a:p>
+        </p:txBody>
+      </p:sp>
+      <p:sp>
+        <p:nvSpPr>
+          <p:cNvPr id="4" name="Slide Number Placeholder 3"/>
+          <p:cNvSpPr>
+            <a:spLocks noGrp="1"/>
+          </p:cNvSpPr>
+          <p:nvPr>
+            <p:ph type="sldNum" sz="quarter" idx="10"/>
+          </p:nvPr>
+        </p:nvSpPr>
+        <p:spPr/>
+        <p:txBody>
+          <a:bodyPr/>
+          <a:lstStyle/>
+          <a:p>
+            <a:fld id="{F7021451-1387-4CA6-816F-3879F97B5CBC}" type="slidenum">
+              <a:rPr lang="en-US"/>
+              <a:t>17</a:t>
+            </a:fld>
+            <a:endParaRPr lang="en-US"/>
+          </a:p>
+        </p:txBody>
+      </p:sp>
+    </p:spTree>
+    <p:extLst>
+      <p:ext uri="{BB962C8B-B14F-4D97-AF65-F5344CB8AC3E}">
+        <p14:creationId xmlns:p14="http://schemas.microsoft.com/office/powerpoint/2010/main" val="1024086991"/>
+      </p:ext>
+    </p:extLst>
+  </p:cSld>
+  <p:clrMapOvr>
+    <a:masterClrMapping/>
+  </p:clrMapOvr>
+</p:notes>
+</file>
+
+<file path=ppt/notesSlides/notesSlide18.xml><?xml version="1.0" encoding="utf-8"?>
+<p:notes xmlns:a="http://schemas.openxmlformats.org/drawingml/2006/main" xmlns:r="http://schemas.openxmlformats.org/officeDocument/2006/relationships" xmlns:p="http://schemas.openxmlformats.org/presentationml/2006/main">
+  <p:cSld>
+    <p:spTree>
+      <p:nvGrpSpPr>
+        <p:cNvPr id="1" name=""/>
+        <p:cNvGrpSpPr/>
+        <p:nvPr/>
+      </p:nvGrpSpPr>
+      <p:grpSpPr>
+        <a:xfrm>
+          <a:off x="0" y="0"/>
+          <a:ext cx="0" cy="0"/>
+          <a:chOff x="0" y="0"/>
+          <a:chExt cx="0" cy="0"/>
+        </a:xfrm>
+      </p:grpSpPr>
+      <p:sp>
+        <p:nvSpPr>
+          <p:cNvPr id="2" name="Slide Image Placeholder 1"/>
+          <p:cNvSpPr>
+            <a:spLocks noGrp="1" noRot="1" noChangeAspect="1"/>
+          </p:cNvSpPr>
+          <p:nvPr>
+            <p:ph type="sldImg"/>
+          </p:nvPr>
+        </p:nvSpPr>
+        <p:spPr/>
+      </p:sp>
+      <p:sp>
+        <p:nvSpPr>
+          <p:cNvPr id="3" name="Notes Placeholder 2"/>
+          <p:cNvSpPr>
+            <a:spLocks noGrp="1"/>
+          </p:cNvSpPr>
+          <p:nvPr>
+            <p:ph type="body" idx="1"/>
+          </p:nvPr>
+        </p:nvSpPr>
+        <p:spPr/>
+        <p:txBody>
+          <a:bodyPr/>
+          <a:lstStyle/>
+          <a:p>
+            <a:r>
+              <a:rPr lang="en-US" dirty="0"/>
+              <a:t/>
+            </a:r>
+            <a:endParaRPr lang="en-US" dirty="0"/>
+          </a:p>
+        </p:txBody>
+      </p:sp>
+      <p:sp>
+        <p:nvSpPr>
+          <p:cNvPr id="4" name="Slide Number Placeholder 3"/>
+          <p:cNvSpPr>
+            <a:spLocks noGrp="1"/>
+          </p:cNvSpPr>
+          <p:nvPr>
+            <p:ph type="sldNum" sz="quarter" idx="10"/>
+          </p:nvPr>
+        </p:nvSpPr>
+        <p:spPr/>
+        <p:txBody>
+          <a:bodyPr/>
+          <a:lstStyle/>
+          <a:p>
+            <a:fld id="{F7021451-1387-4CA6-816F-3879F97B5CBC}" type="slidenum">
+              <a:rPr lang="en-US"/>
+              <a:t>18</a:t>
+            </a:fld>
+            <a:endParaRPr lang="en-US"/>
+          </a:p>
+        </p:txBody>
+      </p:sp>
+    </p:spTree>
+    <p:extLst>
+      <p:ext uri="{BB962C8B-B14F-4D97-AF65-F5344CB8AC3E}">
+        <p14:creationId xmlns:p14="http://schemas.microsoft.com/office/powerpoint/2010/main" val="1024086991"/>
+      </p:ext>
+    </p:extLst>
+  </p:cSld>
+  <p:clrMapOvr>
+    <a:masterClrMapping/>
+  </p:clrMapOvr>
+</p:notes>
+</file>
+
+<file path=ppt/notesSlides/notesSlide19.xml><?xml version="1.0" encoding="utf-8"?>
+<p:notes xmlns:a="http://schemas.openxmlformats.org/drawingml/2006/main" xmlns:r="http://schemas.openxmlformats.org/officeDocument/2006/relationships" xmlns:p="http://schemas.openxmlformats.org/presentationml/2006/main">
+  <p:cSld>
+    <p:spTree>
+      <p:nvGrpSpPr>
+        <p:cNvPr id="1" name=""/>
+        <p:cNvGrpSpPr/>
+        <p:nvPr/>
+      </p:nvGrpSpPr>
+      <p:grpSpPr>
+        <a:xfrm>
+          <a:off x="0" y="0"/>
+          <a:ext cx="0" cy="0"/>
+          <a:chOff x="0" y="0"/>
+          <a:chExt cx="0" cy="0"/>
+        </a:xfrm>
+      </p:grpSpPr>
+      <p:sp>
+        <p:nvSpPr>
+          <p:cNvPr id="2" name="Slide Image Placeholder 1"/>
+          <p:cNvSpPr>
+            <a:spLocks noGrp="1" noRot="1" noChangeAspect="1"/>
+          </p:cNvSpPr>
+          <p:nvPr>
+            <p:ph type="sldImg"/>
+          </p:nvPr>
+        </p:nvSpPr>
+        <p:spPr/>
+      </p:sp>
+      <p:sp>
+        <p:nvSpPr>
+          <p:cNvPr id="3" name="Notes Placeholder 2"/>
+          <p:cNvSpPr>
+            <a:spLocks noGrp="1"/>
+          </p:cNvSpPr>
+          <p:nvPr>
+            <p:ph type="body" idx="1"/>
+          </p:nvPr>
+        </p:nvSpPr>
+        <p:spPr/>
+        <p:txBody>
+          <a:bodyPr/>
+          <a:lstStyle/>
+          <a:p>
+            <a:r>
+              <a:rPr lang="en-US" dirty="0"/>
+              <a:t/>
+            </a:r>
+            <a:endParaRPr lang="en-US" dirty="0"/>
+          </a:p>
+        </p:txBody>
+      </p:sp>
+      <p:sp>
+        <p:nvSpPr>
+          <p:cNvPr id="4" name="Slide Number Placeholder 3"/>
+          <p:cNvSpPr>
+            <a:spLocks noGrp="1"/>
+          </p:cNvSpPr>
+          <p:nvPr>
+            <p:ph type="sldNum" sz="quarter" idx="10"/>
+          </p:nvPr>
+        </p:nvSpPr>
+        <p:spPr/>
+        <p:txBody>
+          <a:bodyPr/>
+          <a:lstStyle/>
+          <a:p>
+            <a:fld id="{F7021451-1387-4CA6-816F-3879F97B5CBC}" type="slidenum">
+              <a:rPr lang="en-US"/>
+              <a:t>19</a:t>
+            </a:fld>
+            <a:endParaRPr lang="en-US"/>
+          </a:p>
+        </p:txBody>
+      </p:sp>
+    </p:spTree>
+    <p:extLst>
+      <p:ext uri="{BB962C8B-B14F-4D97-AF65-F5344CB8AC3E}">
+        <p14:creationId xmlns:p14="http://schemas.microsoft.com/office/powerpoint/2010/main" val="1024086991"/>
+      </p:ext>
+    </p:extLst>
+  </p:cSld>
+  <p:clrMapOvr>
+    <a:masterClrMapping/>
+  </p:clrMapOvr>
+</p:notes>
+</file>
+
 <file path=ppt/notesSlides/notesSlide2.xml><?xml version="1.0" encoding="utf-8"?>
 <p:notes xmlns:a="http://schemas.openxmlformats.org/drawingml/2006/main" xmlns:r="http://schemas.openxmlformats.org/officeDocument/2006/relationships" xmlns:p="http://schemas.openxmlformats.org/presentationml/2006/main">
   <p:cSld>
@@ -1245,6 +1513,94 @@
             <a:fld id="{F7021451-1387-4CA6-816F-3879F97B5CBC}" type="slidenum">
               <a:rPr lang="en-US"/>
               <a:t>2</a:t>
+            </a:fld>
+            <a:endParaRPr lang="en-US"/>
+          </a:p>
+        </p:txBody>
+      </p:sp>
+    </p:spTree>
+    <p:extLst>
+      <p:ext uri="{BB962C8B-B14F-4D97-AF65-F5344CB8AC3E}">
+        <p14:creationId xmlns:p14="http://schemas.microsoft.com/office/powerpoint/2010/main" val="1024086991"/>
+      </p:ext>
+    </p:extLst>
+  </p:cSld>
+  <p:clrMapOvr>
+    <a:masterClrMapping/>
+  </p:clrMapOvr>
+</p:notes>
+</file>
+
+<file path=ppt/notesSlides/notesSlide20.xml><?xml version="1.0" encoding="utf-8"?>
+<p:notes xmlns:a="http://schemas.openxmlformats.org/drawingml/2006/main" xmlns:r="http://schemas.openxmlformats.org/officeDocument/2006/relationships" xmlns:p="http://schemas.openxmlformats.org/presentationml/2006/main">
+  <p:cSld>
+    <p:spTree>
+      <p:nvGrpSpPr>
+        <p:cNvPr id="1" name=""/>
+        <p:cNvGrpSpPr/>
+        <p:nvPr/>
+      </p:nvGrpSpPr>
+      <p:grpSpPr>
+        <a:xfrm>
+          <a:off x="0" y="0"/>
+          <a:ext cx="0" cy="0"/>
+          <a:chOff x="0" y="0"/>
+          <a:chExt cx="0" cy="0"/>
+        </a:xfrm>
+      </p:grpSpPr>
+      <p:sp>
+        <p:nvSpPr>
+          <p:cNvPr id="2" name="Slide Image Placeholder 1"/>
+          <p:cNvSpPr>
+            <a:spLocks noGrp="1" noRot="1" noChangeAspect="1"/>
+          </p:cNvSpPr>
+          <p:nvPr>
+            <p:ph type="sldImg"/>
+          </p:nvPr>
+        </p:nvSpPr>
+        <p:spPr/>
+      </p:sp>
+      <p:sp>
+        <p:nvSpPr>
+          <p:cNvPr id="3" name="Notes Placeholder 2"/>
+          <p:cNvSpPr>
+            <a:spLocks noGrp="1"/>
+          </p:cNvSpPr>
+          <p:nvPr>
+            <p:ph type="body" idx="1"/>
+          </p:nvPr>
+        </p:nvSpPr>
+        <p:spPr/>
+        <p:txBody>
+          <a:bodyPr/>
+          <a:lstStyle/>
+          <a:p>
+            <a:r>
+              <a:rPr lang="en-US" dirty="0"/>
+              <a:t/>
+            </a:r>
+            <a:endParaRPr lang="en-US" dirty="0"/>
+          </a:p>
+        </p:txBody>
+      </p:sp>
+      <p:sp>
+        <p:nvSpPr>
+          <p:cNvPr id="4" name="Slide Number Placeholder 3"/>
+          <p:cNvSpPr>
+            <a:spLocks noGrp="1"/>
+          </p:cNvSpPr>
+          <p:nvPr>
+            <p:ph type="sldNum" sz="quarter" idx="10"/>
+          </p:nvPr>
+        </p:nvSpPr>
+        <p:spPr/>
+        <p:txBody>
+          <a:bodyPr/>
+          <a:lstStyle/>
+          <a:p>
+            <a:fld id="{F7021451-1387-4CA6-816F-3879F97B5CBC}" type="slidenum">
+              <a:rPr lang="en-US"/>
+              <a:t>20</a:t>
             </a:fld>
             <a:endParaRPr lang="en-US"/>
           </a:p>
@@ -2368,7 +2724,7 @@
         <p:spPr>
           <a:xfrm>
             <a:off x="640080" y="502920"/>
-            <a:ext cx="1527048" cy="365760"/>
+            <a:ext cx="1728216" cy="365760"/>
           </a:xfrm>
           <a:prstGeom prst="roundRect">
             <a:avLst>
@@ -2392,7 +2748,7 @@
         <p:spPr>
           <a:xfrm>
             <a:off x="640080" y="502920"/>
-            <a:ext cx="1527048" cy="365760"/>
+            <a:ext cx="1728216" cy="365760"/>
           </a:xfrm>
           <a:prstGeom prst="rect">
             <a:avLst/>
@@ -2416,7 +2772,7 @@
                 <a:ea typeface="Calibri" pitchFamily="34" charset="-122"/>
                 <a:cs typeface="Calibri" pitchFamily="34" charset="-120"/>
               </a:rPr>
-              <a:t>✍️ Your turn</a:t>
+              <a:t>🤔 Guess first</a:t>
             </a:r>
             <a:endParaRPr lang="en-US" sz="1200" dirty="0"/>
           </a:p>
@@ -2455,7 +2811,7 @@
                 <a:ea typeface="Calibri" pitchFamily="34" charset="-122"/>
                 <a:cs typeface="Calibri" pitchFamily="34" charset="-120"/>
               </a:rPr>
-              <a:t>🖨️ Tom's padel grips</a:t>
+              <a:t>🎾 Padel bookings (elastic)</a:t>
             </a:r>
             <a:endParaRPr lang="en-US" sz="2200" dirty="0"/>
           </a:p>
@@ -2516,7 +2872,7 @@
                 <a:ea typeface="Calibri" pitchFamily="34" charset="-122"/>
                 <a:cs typeface="Calibri" pitchFamily="34" charset="-120"/>
               </a:rPr>
-              <a:t>Your turn — work it out</a:t>
+              <a:t>Guess before you check</a:t>
             </a:r>
             <a:endParaRPr lang="en-US" sz="1400" dirty="0"/>
           </a:p>
@@ -2531,7 +2887,7 @@
         <p:spPr>
           <a:xfrm>
             <a:off x="3840480" y="2651760"/>
-            <a:ext cx="4480560" cy="1280160"/>
+            <a:ext cx="4480560" cy="1463040"/>
           </a:xfrm>
           <a:prstGeom prst="rect">
             <a:avLst/>
@@ -2545,7 +2901,7 @@
           <a:p>
             <a:pPr indent="0" marL="0">
               <a:spcAft>
-                <a:spcPts val="800"/>
+                <a:spcPts val="600"/>
               </a:spcAft>
               <a:buNone/>
             </a:pPr>
@@ -2558,14 +2914,14 @@
                 <a:ea typeface="Calibri" pitchFamily="34" charset="-122"/>
                 <a:cs typeface="Calibri" pitchFamily="34" charset="-120"/>
               </a:rPr>
-              <a:t>Price: $8 → $10</a:t>
+              <a:t>Price: $20 → $22  (+10%)</a:t>
             </a:r>
             <a:endParaRPr lang="en-US" sz="1500" dirty="0"/>
           </a:p>
           <a:p>
             <a:pPr indent="0" marL="0">
               <a:spcAft>
-                <a:spcPts val="800"/>
+                <a:spcPts val="600"/>
               </a:spcAft>
               <a:buNone/>
             </a:pPr>
@@ -2578,14 +2934,14 @@
                 <a:ea typeface="Calibri" pitchFamily="34" charset="-122"/>
                 <a:cs typeface="Calibri" pitchFamily="34" charset="-120"/>
               </a:rPr>
-              <a:t>Quantity: 60 → 54</a:t>
+              <a:t>Quantity: 100 → 80 bookings/week  (−20%)</a:t>
             </a:r>
             <a:endParaRPr lang="en-US" sz="1500" dirty="0"/>
           </a:p>
           <a:p>
             <a:pPr indent="0" marL="0">
               <a:spcAft>
-                <a:spcPts val="800"/>
+                <a:spcPts val="600"/>
               </a:spcAft>
               <a:buNone/>
             </a:pPr>
@@ -2598,7 +2954,7 @@
                 <a:ea typeface="Calibri" pitchFamily="34" charset="-122"/>
                 <a:cs typeface="Calibri" pitchFamily="34" charset="-120"/>
               </a:rPr>
-              <a:t>(PED = −0.4, from last lesson)</a:t>
+              <a:t>PED = −2 (elastic)</a:t>
             </a:r>
             <a:endParaRPr lang="en-US" sz="1500" dirty="0"/>
           </a:p>
@@ -2606,42 +2962,19 @@
       </p:sp>
       <p:sp>
         <p:nvSpPr>
-          <p:cNvPr id="8" name="Shape 6"/>
-          <p:cNvSpPr/>
-          <p:nvPr/>
-        </p:nvSpPr>
-        <p:spPr>
-          <a:xfrm>
-            <a:off x="3840480" y="4343400"/>
-            <a:ext cx="1828800" cy="0"/>
-          </a:xfrm>
-          <a:prstGeom prst="line">
+          <p:cNvPr id="8" name="Text 6"/>
+          <p:cNvSpPr/>
+          <p:nvPr/>
+        </p:nvSpPr>
+        <p:spPr>
+          <a:xfrm>
+            <a:off x="3840480" y="4206240"/>
+            <a:ext cx="4480560" cy="731520"/>
+          </a:xfrm>
+          <a:prstGeom prst="rect">
             <a:avLst/>
           </a:prstGeom>
           <a:noFill/>
-          <a:ln w="19050">
-            <a:solidFill>
-              <a:srgbClr val="5B5B5B"/>
-            </a:solidFill>
-            <a:prstDash val="solid"/>
-          </a:ln>
-        </p:spPr>
-      </p:sp>
-      <p:sp>
-        <p:nvSpPr>
-          <p:cNvPr id="9" name="Text 7"/>
-          <p:cNvSpPr/>
-          <p:nvPr/>
-        </p:nvSpPr>
-        <p:spPr>
-          <a:xfrm>
-            <a:off x="3840480" y="3977640"/>
-            <a:ext cx="4206240" cy="320040"/>
-          </a:xfrm>
-          <a:prstGeom prst="rect">
-            <a:avLst/>
-          </a:prstGeom>
-          <a:noFill/>
           <a:ln/>
         </p:spPr>
         <p:txBody>
@@ -2652,79 +2985,17 @@
               <a:buNone/>
             </a:pPr>
             <a:r>
-              <a:rPr lang="en-US" sz="1400" dirty="0">
-                <a:solidFill>
-                  <a:srgbClr val="1A1A1A"/>
-                </a:solidFill>
-                <a:latin typeface="Calibri" pitchFamily="34" charset="0"/>
-                <a:ea typeface="Calibri" pitchFamily="34" charset="-122"/>
-                <a:cs typeface="Calibri" pitchFamily="34" charset="-120"/>
-              </a:rPr>
-              <a:t>TR before = $____</a:t>
-            </a:r>
-            <a:endParaRPr lang="en-US" sz="1400" dirty="0"/>
-          </a:p>
-        </p:txBody>
-      </p:sp>
-      <p:sp>
-        <p:nvSpPr>
-          <p:cNvPr id="10" name="Shape 8"/>
-          <p:cNvSpPr/>
-          <p:nvPr/>
-        </p:nvSpPr>
-        <p:spPr>
-          <a:xfrm>
-            <a:off x="3840480" y="4709160"/>
-            <a:ext cx="1828800" cy="0"/>
-          </a:xfrm>
-          <a:prstGeom prst="line">
-            <a:avLst/>
-          </a:prstGeom>
-          <a:noFill/>
-          <a:ln w="19050">
-            <a:solidFill>
-              <a:srgbClr val="5B5B5B"/>
-            </a:solidFill>
-            <a:prstDash val="solid"/>
-          </a:ln>
-        </p:spPr>
-      </p:sp>
-      <p:sp>
-        <p:nvSpPr>
-          <p:cNvPr id="11" name="Text 9"/>
-          <p:cNvSpPr/>
-          <p:nvPr/>
-        </p:nvSpPr>
-        <p:spPr>
-          <a:xfrm>
-            <a:off x="3840480" y="4343400"/>
-            <a:ext cx="4206240" cy="320040"/>
-          </a:xfrm>
-          <a:prstGeom prst="rect">
-            <a:avLst/>
-          </a:prstGeom>
-          <a:noFill/>
-          <a:ln/>
-        </p:spPr>
-        <p:txBody>
-          <a:bodyPr wrap="square" rtlCol="0" anchor="ctr"/>
-          <a:lstStyle/>
-          <a:p>
-            <a:pPr indent="0" marL="0">
-              <a:buNone/>
-            </a:pPr>
-            <a:r>
-              <a:rPr lang="en-US" sz="1400" dirty="0">
-                <a:solidFill>
-                  <a:srgbClr val="1A1A1A"/>
-                </a:solidFill>
-                <a:latin typeface="Calibri" pitchFamily="34" charset="0"/>
-                <a:ea typeface="Calibri" pitchFamily="34" charset="-122"/>
-                <a:cs typeface="Calibri" pitchFamily="34" charset="-120"/>
-              </a:rPr>
-              <a:t>TR after = $____</a:t>
-            </a:r>
-            <a:endParaRPr lang="en-US" sz="1400" dirty="0"/>
+              <a:rPr lang="en-US" sz="1800" b="1" dirty="0">
+                <a:solidFill>
+                  <a:srgbClr val="1E2761"/>
+                </a:solidFill>
+                <a:latin typeface="Cambria" pitchFamily="34" charset="0"/>
+                <a:ea typeface="Cambria" pitchFamily="34" charset="-122"/>
+                <a:cs typeface="Cambria" pitchFamily="34" charset="-120"/>
+              </a:rPr>
+              <a:t>Revenue: up, down, or the same?</a:t>
+            </a:r>
+            <a:endParaRPr lang="en-US" sz="1800" dirty="0"/>
           </a:p>
         </p:txBody>
       </p:sp>
@@ -2856,7 +3127,7 @@
                 <a:ea typeface="Calibri" pitchFamily="34" charset="-122"/>
                 <a:cs typeface="Calibri" pitchFamily="34" charset="-120"/>
               </a:rPr>
-              <a:t>🖨️ Tom's grips — answer</a:t>
+              <a:t>🎾 Padel bookings — answer</a:t>
             </a:r>
             <a:endParaRPr lang="en-US" sz="2200" dirty="0"/>
           </a:p>
@@ -2917,7 +3188,7 @@
                 <a:ea typeface="Calibri" pitchFamily="34" charset="-122"/>
                 <a:cs typeface="Calibri" pitchFamily="34" charset="-120"/>
               </a:rPr>
-              <a:t>Check your answer</a:t>
+              <a:t>The reveal</a:t>
             </a:r>
             <a:endParaRPr lang="en-US" sz="1400" dirty="0"/>
           </a:p>
@@ -2959,7 +3230,7 @@
                 <a:ea typeface="Calibri" pitchFamily="34" charset="-122"/>
                 <a:cs typeface="Calibri" pitchFamily="34" charset="-120"/>
               </a:rPr>
-              <a:t>TR before = $8 × 60 = $480</a:t>
+              <a:t>TR before = $20 × 100 = $2000</a:t>
             </a:r>
             <a:endParaRPr lang="en-US" sz="1500" dirty="0"/>
           </a:p>
@@ -2979,7 +3250,7 @@
                 <a:ea typeface="Calibri" pitchFamily="34" charset="-122"/>
                 <a:cs typeface="Calibri" pitchFamily="34" charset="-120"/>
               </a:rPr>
-              <a:t>TR after = $10 × 54 = $540</a:t>
+              <a:t>TR after = $22 × 80 = $1760</a:t>
             </a:r>
             <a:endParaRPr lang="en-US" sz="1500" dirty="0"/>
           </a:p>
@@ -3018,7 +3289,7 @@
                 <a:ea typeface="Cambria" pitchFamily="34" charset="-122"/>
                 <a:cs typeface="Cambria" pitchFamily="34" charset="-120"/>
               </a:rPr>
-              <a:t>Revenue rose — inelastic, again</a:t>
+              <a:t>Revenue FELL, despite the price rise</a:t>
             </a:r>
             <a:endParaRPr lang="en-US" sz="1800" dirty="0"/>
           </a:p>
@@ -3058,14 +3329,38 @@
       </p:grpSpPr>
       <p:sp>
         <p:nvSpPr>
-          <p:cNvPr id="2" name="Text 0"/>
-          <p:cNvSpPr/>
-          <p:nvPr/>
-        </p:nvSpPr>
-        <p:spPr>
-          <a:xfrm>
-            <a:off x="640080" y="548640"/>
-            <a:ext cx="10881360" cy="731520"/>
+          <p:cNvPr id="2" name="Shape 0"/>
+          <p:cNvSpPr/>
+          <p:nvPr/>
+        </p:nvSpPr>
+        <p:spPr>
+          <a:xfrm>
+            <a:off x="640080" y="502920"/>
+            <a:ext cx="1728216" cy="365760"/>
+          </a:xfrm>
+          <a:prstGeom prst="roundRect">
+            <a:avLst>
+              <a:gd name="adj" fmla="val 50000"/>
+            </a:avLst>
+          </a:prstGeom>
+          <a:solidFill>
+            <a:srgbClr val="F96167">
+              <a:alpha val="18000"/>
+            </a:srgbClr>
+          </a:solidFill>
+          <a:ln/>
+        </p:spPr>
+      </p:sp>
+      <p:sp>
+        <p:nvSpPr>
+          <p:cNvPr id="3" name="Text 1"/>
+          <p:cNvSpPr/>
+          <p:nvPr/>
+        </p:nvSpPr>
+        <p:spPr>
+          <a:xfrm>
+            <a:off x="640080" y="502920"/>
+            <a:ext cx="1728216" cy="365760"/>
           </a:xfrm>
           <a:prstGeom prst="rect">
             <a:avLst/>
@@ -3077,11 +3372,232 @@
           <a:bodyPr wrap="square" rtlCol="0" anchor="ctr"/>
           <a:lstStyle/>
           <a:p>
+            <a:pPr algn="ctr" indent="0" marL="0">
+              <a:buNone/>
+            </a:pPr>
+            <a:r>
+              <a:rPr lang="en-US" sz="1200" b="1" dirty="0">
+                <a:solidFill>
+                  <a:srgbClr val="F96167"/>
+                </a:solidFill>
+                <a:latin typeface="Calibri" pitchFamily="34" charset="0"/>
+                <a:ea typeface="Calibri" pitchFamily="34" charset="-122"/>
+                <a:cs typeface="Calibri" pitchFamily="34" charset="-120"/>
+              </a:rPr>
+              <a:t>🤔 Guess first</a:t>
+            </a:r>
+            <a:endParaRPr lang="en-US" sz="1200" dirty="0"/>
+          </a:p>
+        </p:txBody>
+      </p:sp>
+      <p:sp>
+        <p:nvSpPr>
+          <p:cNvPr id="4" name="Text 2"/>
+          <p:cNvSpPr/>
+          <p:nvPr/>
+        </p:nvSpPr>
+        <p:spPr>
+          <a:xfrm>
+            <a:off x="640080" y="1051560"/>
+            <a:ext cx="10881360" cy="548640"/>
+          </a:xfrm>
+          <a:prstGeom prst="rect">
+            <a:avLst/>
+          </a:prstGeom>
+          <a:noFill/>
+          <a:ln/>
+        </p:spPr>
+        <p:txBody>
+          <a:bodyPr wrap="square" rtlCol="0" anchor="ctr"/>
+          <a:lstStyle/>
+          <a:p>
             <a:pPr indent="0" marL="0">
               <a:buNone/>
             </a:pPr>
             <a:r>
-              <a:rPr lang="en-US" sz="3200" b="1" dirty="0">
+              <a:rPr lang="en-US" sz="2200" b="1" dirty="0">
+                <a:solidFill>
+                  <a:srgbClr val="1E2761"/>
+                </a:solidFill>
+                <a:latin typeface="Calibri" pitchFamily="34" charset="0"/>
+                <a:ea typeface="Calibri" pitchFamily="34" charset="-122"/>
+                <a:cs typeface="Calibri" pitchFamily="34" charset="-120"/>
+              </a:rPr>
+              <a:t>🧩 Retired Lego set (inelastic)</a:t>
+            </a:r>
+            <a:endParaRPr lang="en-US" sz="2200" dirty="0"/>
+          </a:p>
+        </p:txBody>
+      </p:sp>
+      <p:sp>
+        <p:nvSpPr>
+          <p:cNvPr id="5" name="Shape 3"/>
+          <p:cNvSpPr/>
+          <p:nvPr/>
+        </p:nvSpPr>
+        <p:spPr>
+          <a:xfrm>
+            <a:off x="3566160" y="1920240"/>
+            <a:ext cx="5029200" cy="3108960"/>
+          </a:xfrm>
+          <a:prstGeom prst="roundRect">
+            <a:avLst>
+              <a:gd name="adj" fmla="val 4118"/>
+            </a:avLst>
+          </a:prstGeom>
+          <a:solidFill>
+            <a:srgbClr val="F4F5F7"/>
+          </a:solidFill>
+          <a:ln/>
+        </p:spPr>
+      </p:sp>
+      <p:sp>
+        <p:nvSpPr>
+          <p:cNvPr id="6" name="Text 4"/>
+          <p:cNvSpPr/>
+          <p:nvPr/>
+        </p:nvSpPr>
+        <p:spPr>
+          <a:xfrm>
+            <a:off x="3840480" y="2194560"/>
+            <a:ext cx="4480560" cy="365760"/>
+          </a:xfrm>
+          <a:prstGeom prst="rect">
+            <a:avLst/>
+          </a:prstGeom>
+          <a:noFill/>
+          <a:ln/>
+        </p:spPr>
+        <p:txBody>
+          <a:bodyPr wrap="square" rtlCol="0" anchor="ctr"/>
+          <a:lstStyle/>
+          <a:p>
+            <a:pPr indent="0" marL="0">
+              <a:buNone/>
+            </a:pPr>
+            <a:r>
+              <a:rPr lang="en-US" sz="1400" b="1" dirty="0">
+                <a:solidFill>
+                  <a:srgbClr val="5B5B5B"/>
+                </a:solidFill>
+                <a:latin typeface="Calibri" pitchFamily="34" charset="0"/>
+                <a:ea typeface="Calibri" pitchFamily="34" charset="-122"/>
+                <a:cs typeface="Calibri" pitchFamily="34" charset="-120"/>
+              </a:rPr>
+              <a:t>Guess before you check</a:t>
+            </a:r>
+            <a:endParaRPr lang="en-US" sz="1400" dirty="0"/>
+          </a:p>
+        </p:txBody>
+      </p:sp>
+      <p:sp>
+        <p:nvSpPr>
+          <p:cNvPr id="7" name="Text 5"/>
+          <p:cNvSpPr/>
+          <p:nvPr/>
+        </p:nvSpPr>
+        <p:spPr>
+          <a:xfrm>
+            <a:off x="3840480" y="2651760"/>
+            <a:ext cx="4480560" cy="1463040"/>
+          </a:xfrm>
+          <a:prstGeom prst="rect">
+            <a:avLst/>
+          </a:prstGeom>
+          <a:noFill/>
+          <a:ln/>
+        </p:spPr>
+        <p:txBody>
+          <a:bodyPr wrap="square" rtlCol="0" anchor="t"/>
+          <a:lstStyle/>
+          <a:p>
+            <a:pPr indent="0" marL="0">
+              <a:spcAft>
+                <a:spcPts val="600"/>
+              </a:spcAft>
+              <a:buNone/>
+            </a:pPr>
+            <a:r>
+              <a:rPr lang="en-US" sz="1500" dirty="0">
+                <a:solidFill>
+                  <a:srgbClr val="1A1A1A"/>
+                </a:solidFill>
+                <a:latin typeface="Calibri" pitchFamily="34" charset="0"/>
+                <a:ea typeface="Calibri" pitchFamily="34" charset="-122"/>
+                <a:cs typeface="Calibri" pitchFamily="34" charset="-120"/>
+              </a:rPr>
+              <a:t>Price: $50 → $55  (+10%)</a:t>
+            </a:r>
+            <a:endParaRPr lang="en-US" sz="1500" dirty="0"/>
+          </a:p>
+          <a:p>
+            <a:pPr indent="0" marL="0">
+              <a:spcAft>
+                <a:spcPts val="600"/>
+              </a:spcAft>
+              <a:buNone/>
+            </a:pPr>
+            <a:r>
+              <a:rPr lang="en-US" sz="1500" dirty="0">
+                <a:solidFill>
+                  <a:srgbClr val="1A1A1A"/>
+                </a:solidFill>
+                <a:latin typeface="Calibri" pitchFamily="34" charset="0"/>
+                <a:ea typeface="Calibri" pitchFamily="34" charset="-122"/>
+                <a:cs typeface="Calibri" pitchFamily="34" charset="-120"/>
+              </a:rPr>
+              <a:t>Quantity: 40 → 38 sets/month  (−5%)</a:t>
+            </a:r>
+            <a:endParaRPr lang="en-US" sz="1500" dirty="0"/>
+          </a:p>
+          <a:p>
+            <a:pPr indent="0" marL="0">
+              <a:spcAft>
+                <a:spcPts val="600"/>
+              </a:spcAft>
+              <a:buNone/>
+            </a:pPr>
+            <a:r>
+              <a:rPr lang="en-US" sz="1500" dirty="0">
+                <a:solidFill>
+                  <a:srgbClr val="1A1A1A"/>
+                </a:solidFill>
+                <a:latin typeface="Calibri" pitchFamily="34" charset="0"/>
+                <a:ea typeface="Calibri" pitchFamily="34" charset="-122"/>
+                <a:cs typeface="Calibri" pitchFamily="34" charset="-120"/>
+              </a:rPr>
+              <a:t>PED = −0.5 (inelastic)</a:t>
+            </a:r>
+            <a:endParaRPr lang="en-US" sz="1500" dirty="0"/>
+          </a:p>
+        </p:txBody>
+      </p:sp>
+      <p:sp>
+        <p:nvSpPr>
+          <p:cNvPr id="8" name="Text 6"/>
+          <p:cNvSpPr/>
+          <p:nvPr/>
+        </p:nvSpPr>
+        <p:spPr>
+          <a:xfrm>
+            <a:off x="3840480" y="4206240"/>
+            <a:ext cx="4480560" cy="731520"/>
+          </a:xfrm>
+          <a:prstGeom prst="rect">
+            <a:avLst/>
+          </a:prstGeom>
+          <a:noFill/>
+          <a:ln/>
+        </p:spPr>
+        <p:txBody>
+          <a:bodyPr wrap="square" rtlCol="0" anchor="ctr"/>
+          <a:lstStyle/>
+          <a:p>
+            <a:pPr indent="0" marL="0">
+              <a:buNone/>
+            </a:pPr>
+            <a:r>
+              <a:rPr lang="en-US" sz="1800" b="1" dirty="0">
                 <a:solidFill>
                   <a:srgbClr val="1E2761"/>
                 </a:solidFill>
@@ -3089,6 +3605,1070 @@
                 <a:ea typeface="Cambria" pitchFamily="34" charset="-122"/>
                 <a:cs typeface="Cambria" pitchFamily="34" charset="-120"/>
               </a:rPr>
+              <a:t>Revenue: up, down, or the same?</a:t>
+            </a:r>
+            <a:endParaRPr lang="en-US" sz="1800" dirty="0"/>
+          </a:p>
+        </p:txBody>
+      </p:sp>
+    </p:spTree>
+  </p:cSld>
+  <p:clrMapOvr>
+    <a:masterClrMapping/>
+  </p:clrMapOvr>
+</p:sld>
+</file>
+
+<file path=ppt/slides/slide13.xml><?xml version="1.0" encoding="utf-8"?>
+<p:sld xmlns:a="http://schemas.openxmlformats.org/drawingml/2006/main" xmlns:r="http://schemas.openxmlformats.org/officeDocument/2006/relationships" xmlns:p="http://schemas.openxmlformats.org/presentationml/2006/main">
+  <p:cSld name="Slide 13">
+    <p:bg>
+      <p:bgPr>
+        <a:solidFill>
+          <a:srgbClr val="FFFFFF"/>
+        </a:solidFill>
+      </p:bgPr>
+    </p:bg>
+    <p:spTree>
+      <p:nvGrpSpPr>
+        <p:cNvPr id="1" name=""/>
+        <p:cNvGrpSpPr/>
+        <p:nvPr/>
+      </p:nvGrpSpPr>
+      <p:grpSpPr>
+        <a:xfrm>
+          <a:off x="0" y="0"/>
+          <a:ext cx="0" cy="0"/>
+          <a:chOff x="0" y="0"/>
+          <a:chExt cx="0" cy="0"/>
+        </a:xfrm>
+      </p:grpSpPr>
+      <p:sp>
+        <p:nvSpPr>
+          <p:cNvPr id="2" name="Shape 0"/>
+          <p:cNvSpPr/>
+          <p:nvPr/>
+        </p:nvSpPr>
+        <p:spPr>
+          <a:xfrm>
+            <a:off x="640080" y="502920"/>
+            <a:ext cx="1325880" cy="365760"/>
+          </a:xfrm>
+          <a:prstGeom prst="roundRect">
+            <a:avLst>
+              <a:gd name="adj" fmla="val 50000"/>
+            </a:avLst>
+          </a:prstGeom>
+          <a:solidFill>
+            <a:srgbClr val="1BAF7A">
+              <a:alpha val="18000"/>
+            </a:srgbClr>
+          </a:solidFill>
+          <a:ln/>
+        </p:spPr>
+      </p:sp>
+      <p:sp>
+        <p:nvSpPr>
+          <p:cNvPr id="3" name="Text 1"/>
+          <p:cNvSpPr/>
+          <p:nvPr/>
+        </p:nvSpPr>
+        <p:spPr>
+          <a:xfrm>
+            <a:off x="640080" y="502920"/>
+            <a:ext cx="1325880" cy="365760"/>
+          </a:xfrm>
+          <a:prstGeom prst="rect">
+            <a:avLst/>
+          </a:prstGeom>
+          <a:noFill/>
+          <a:ln/>
+        </p:spPr>
+        <p:txBody>
+          <a:bodyPr wrap="square" rtlCol="0" anchor="ctr"/>
+          <a:lstStyle/>
+          <a:p>
+            <a:pPr algn="ctr" indent="0" marL="0">
+              <a:buNone/>
+            </a:pPr>
+            <a:r>
+              <a:rPr lang="en-US" sz="1200" b="1" dirty="0">
+                <a:solidFill>
+                  <a:srgbClr val="1BAF7A"/>
+                </a:solidFill>
+                <a:latin typeface="Calibri" pitchFamily="34" charset="0"/>
+                <a:ea typeface="Calibri" pitchFamily="34" charset="-122"/>
+                <a:cs typeface="Calibri" pitchFamily="34" charset="-120"/>
+              </a:rPr>
+              <a:t>✅ Revealed</a:t>
+            </a:r>
+            <a:endParaRPr lang="en-US" sz="1200" dirty="0"/>
+          </a:p>
+        </p:txBody>
+      </p:sp>
+      <p:sp>
+        <p:nvSpPr>
+          <p:cNvPr id="4" name="Text 2"/>
+          <p:cNvSpPr/>
+          <p:nvPr/>
+        </p:nvSpPr>
+        <p:spPr>
+          <a:xfrm>
+            <a:off x="640080" y="1051560"/>
+            <a:ext cx="10881360" cy="548640"/>
+          </a:xfrm>
+          <a:prstGeom prst="rect">
+            <a:avLst/>
+          </a:prstGeom>
+          <a:noFill/>
+          <a:ln/>
+        </p:spPr>
+        <p:txBody>
+          <a:bodyPr wrap="square" rtlCol="0" anchor="ctr"/>
+          <a:lstStyle/>
+          <a:p>
+            <a:pPr indent="0" marL="0">
+              <a:buNone/>
+            </a:pPr>
+            <a:r>
+              <a:rPr lang="en-US" sz="2200" b="1" dirty="0">
+                <a:solidFill>
+                  <a:srgbClr val="1E2761"/>
+                </a:solidFill>
+                <a:latin typeface="Calibri" pitchFamily="34" charset="0"/>
+                <a:ea typeface="Calibri" pitchFamily="34" charset="-122"/>
+                <a:cs typeface="Calibri" pitchFamily="34" charset="-120"/>
+              </a:rPr>
+              <a:t>🧩 Retired Lego set — answer</a:t>
+            </a:r>
+            <a:endParaRPr lang="en-US" sz="2200" dirty="0"/>
+          </a:p>
+        </p:txBody>
+      </p:sp>
+      <p:sp>
+        <p:nvSpPr>
+          <p:cNvPr id="5" name="Shape 3"/>
+          <p:cNvSpPr/>
+          <p:nvPr/>
+        </p:nvSpPr>
+        <p:spPr>
+          <a:xfrm>
+            <a:off x="3566160" y="1920240"/>
+            <a:ext cx="5029200" cy="3108960"/>
+          </a:xfrm>
+          <a:prstGeom prst="roundRect">
+            <a:avLst>
+              <a:gd name="adj" fmla="val 4118"/>
+            </a:avLst>
+          </a:prstGeom>
+          <a:solidFill>
+            <a:srgbClr val="F4F5F7"/>
+          </a:solidFill>
+          <a:ln/>
+        </p:spPr>
+      </p:sp>
+      <p:sp>
+        <p:nvSpPr>
+          <p:cNvPr id="6" name="Text 4"/>
+          <p:cNvSpPr/>
+          <p:nvPr/>
+        </p:nvSpPr>
+        <p:spPr>
+          <a:xfrm>
+            <a:off x="3840480" y="2194560"/>
+            <a:ext cx="4480560" cy="365760"/>
+          </a:xfrm>
+          <a:prstGeom prst="rect">
+            <a:avLst/>
+          </a:prstGeom>
+          <a:noFill/>
+          <a:ln/>
+        </p:spPr>
+        <p:txBody>
+          <a:bodyPr wrap="square" rtlCol="0" anchor="ctr"/>
+          <a:lstStyle/>
+          <a:p>
+            <a:pPr indent="0" marL="0">
+              <a:buNone/>
+            </a:pPr>
+            <a:r>
+              <a:rPr lang="en-US" sz="1400" b="1" dirty="0">
+                <a:solidFill>
+                  <a:srgbClr val="5B5B5B"/>
+                </a:solidFill>
+                <a:latin typeface="Calibri" pitchFamily="34" charset="0"/>
+                <a:ea typeface="Calibri" pitchFamily="34" charset="-122"/>
+                <a:cs typeface="Calibri" pitchFamily="34" charset="-120"/>
+              </a:rPr>
+              <a:t>The reveal</a:t>
+            </a:r>
+            <a:endParaRPr lang="en-US" sz="1400" dirty="0"/>
+          </a:p>
+        </p:txBody>
+      </p:sp>
+      <p:sp>
+        <p:nvSpPr>
+          <p:cNvPr id="7" name="Text 5"/>
+          <p:cNvSpPr/>
+          <p:nvPr/>
+        </p:nvSpPr>
+        <p:spPr>
+          <a:xfrm>
+            <a:off x="3840480" y="2651760"/>
+            <a:ext cx="4480560" cy="1463040"/>
+          </a:xfrm>
+          <a:prstGeom prst="rect">
+            <a:avLst/>
+          </a:prstGeom>
+          <a:noFill/>
+          <a:ln/>
+        </p:spPr>
+        <p:txBody>
+          <a:bodyPr wrap="square" rtlCol="0" anchor="t"/>
+          <a:lstStyle/>
+          <a:p>
+            <a:pPr indent="0" marL="0">
+              <a:spcAft>
+                <a:spcPts val="600"/>
+              </a:spcAft>
+              <a:buNone/>
+            </a:pPr>
+            <a:r>
+              <a:rPr lang="en-US" sz="1500" dirty="0">
+                <a:solidFill>
+                  <a:srgbClr val="1A1A1A"/>
+                </a:solidFill>
+                <a:latin typeface="Calibri" pitchFamily="34" charset="0"/>
+                <a:ea typeface="Calibri" pitchFamily="34" charset="-122"/>
+                <a:cs typeface="Calibri" pitchFamily="34" charset="-120"/>
+              </a:rPr>
+              <a:t>TR before = $50 × 40 = $2000</a:t>
+            </a:r>
+            <a:endParaRPr lang="en-US" sz="1500" dirty="0"/>
+          </a:p>
+          <a:p>
+            <a:pPr indent="0" marL="0">
+              <a:spcAft>
+                <a:spcPts val="600"/>
+              </a:spcAft>
+              <a:buNone/>
+            </a:pPr>
+            <a:r>
+              <a:rPr lang="en-US" sz="1500" dirty="0">
+                <a:solidFill>
+                  <a:srgbClr val="1A1A1A"/>
+                </a:solidFill>
+                <a:latin typeface="Calibri" pitchFamily="34" charset="0"/>
+                <a:ea typeface="Calibri" pitchFamily="34" charset="-122"/>
+                <a:cs typeface="Calibri" pitchFamily="34" charset="-120"/>
+              </a:rPr>
+              <a:t>TR after = $55 × 38 = $2090</a:t>
+            </a:r>
+            <a:endParaRPr lang="en-US" sz="1500" dirty="0"/>
+          </a:p>
+        </p:txBody>
+      </p:sp>
+      <p:sp>
+        <p:nvSpPr>
+          <p:cNvPr id="8" name="Text 6"/>
+          <p:cNvSpPr/>
+          <p:nvPr/>
+        </p:nvSpPr>
+        <p:spPr>
+          <a:xfrm>
+            <a:off x="3840480" y="4206240"/>
+            <a:ext cx="4480560" cy="731520"/>
+          </a:xfrm>
+          <a:prstGeom prst="rect">
+            <a:avLst/>
+          </a:prstGeom>
+          <a:noFill/>
+          <a:ln/>
+        </p:spPr>
+        <p:txBody>
+          <a:bodyPr wrap="square" rtlCol="0" anchor="ctr"/>
+          <a:lstStyle/>
+          <a:p>
+            <a:pPr indent="0" marL="0">
+              <a:buNone/>
+            </a:pPr>
+            <a:r>
+              <a:rPr lang="en-US" sz="1800" b="1" dirty="0">
+                <a:solidFill>
+                  <a:srgbClr val="1BAF7A"/>
+                </a:solidFill>
+                <a:latin typeface="Cambria" pitchFamily="34" charset="0"/>
+                <a:ea typeface="Cambria" pitchFamily="34" charset="-122"/>
+                <a:cs typeface="Cambria" pitchFamily="34" charset="-120"/>
+              </a:rPr>
+              <a:t>Revenue ROSE this time</a:t>
+            </a:r>
+            <a:endParaRPr lang="en-US" sz="1800" dirty="0"/>
+          </a:p>
+        </p:txBody>
+      </p:sp>
+    </p:spTree>
+  </p:cSld>
+  <p:clrMapOvr>
+    <a:masterClrMapping/>
+  </p:clrMapOvr>
+</p:sld>
+</file>
+
+<file path=ppt/slides/slide14.xml><?xml version="1.0" encoding="utf-8"?>
+<p:sld xmlns:a="http://schemas.openxmlformats.org/drawingml/2006/main" xmlns:r="http://schemas.openxmlformats.org/officeDocument/2006/relationships" xmlns:p="http://schemas.openxmlformats.org/presentationml/2006/main">
+  <p:cSld name="Slide 14">
+    <p:bg>
+      <p:bgPr>
+        <a:solidFill>
+          <a:srgbClr val="FFFFFF"/>
+        </a:solidFill>
+      </p:bgPr>
+    </p:bg>
+    <p:spTree>
+      <p:nvGrpSpPr>
+        <p:cNvPr id="1" name=""/>
+        <p:cNvGrpSpPr/>
+        <p:nvPr/>
+      </p:nvGrpSpPr>
+      <p:grpSpPr>
+        <a:xfrm>
+          <a:off x="0" y="0"/>
+          <a:ext cx="0" cy="0"/>
+          <a:chOff x="0" y="0"/>
+          <a:chExt cx="0" cy="0"/>
+        </a:xfrm>
+      </p:grpSpPr>
+      <p:sp>
+        <p:nvSpPr>
+          <p:cNvPr id="2" name="Shape 0"/>
+          <p:cNvSpPr/>
+          <p:nvPr/>
+        </p:nvSpPr>
+        <p:spPr>
+          <a:xfrm>
+            <a:off x="640080" y="502920"/>
+            <a:ext cx="1527048" cy="365760"/>
+          </a:xfrm>
+          <a:prstGeom prst="roundRect">
+            <a:avLst>
+              <a:gd name="adj" fmla="val 50000"/>
+            </a:avLst>
+          </a:prstGeom>
+          <a:solidFill>
+            <a:srgbClr val="F96167">
+              <a:alpha val="18000"/>
+            </a:srgbClr>
+          </a:solidFill>
+          <a:ln/>
+        </p:spPr>
+      </p:sp>
+      <p:sp>
+        <p:nvSpPr>
+          <p:cNvPr id="3" name="Text 1"/>
+          <p:cNvSpPr/>
+          <p:nvPr/>
+        </p:nvSpPr>
+        <p:spPr>
+          <a:xfrm>
+            <a:off x="640080" y="502920"/>
+            <a:ext cx="1527048" cy="365760"/>
+          </a:xfrm>
+          <a:prstGeom prst="rect">
+            <a:avLst/>
+          </a:prstGeom>
+          <a:noFill/>
+          <a:ln/>
+        </p:spPr>
+        <p:txBody>
+          <a:bodyPr wrap="square" rtlCol="0" anchor="ctr"/>
+          <a:lstStyle/>
+          <a:p>
+            <a:pPr algn="ctr" indent="0" marL="0">
+              <a:buNone/>
+            </a:pPr>
+            <a:r>
+              <a:rPr lang="en-US" sz="1200" b="1" dirty="0">
+                <a:solidFill>
+                  <a:srgbClr val="F96167"/>
+                </a:solidFill>
+                <a:latin typeface="Calibri" pitchFamily="34" charset="0"/>
+                <a:ea typeface="Calibri" pitchFamily="34" charset="-122"/>
+                <a:cs typeface="Calibri" pitchFamily="34" charset="-120"/>
+              </a:rPr>
+              <a:t>✍️ Your turn</a:t>
+            </a:r>
+            <a:endParaRPr lang="en-US" sz="1200" dirty="0"/>
+          </a:p>
+        </p:txBody>
+      </p:sp>
+      <p:sp>
+        <p:nvSpPr>
+          <p:cNvPr id="4" name="Text 2"/>
+          <p:cNvSpPr/>
+          <p:nvPr/>
+        </p:nvSpPr>
+        <p:spPr>
+          <a:xfrm>
+            <a:off x="640080" y="1051560"/>
+            <a:ext cx="10881360" cy="548640"/>
+          </a:xfrm>
+          <a:prstGeom prst="rect">
+            <a:avLst/>
+          </a:prstGeom>
+          <a:noFill/>
+          <a:ln/>
+        </p:spPr>
+        <p:txBody>
+          <a:bodyPr wrap="square" rtlCol="0" anchor="ctr"/>
+          <a:lstStyle/>
+          <a:p>
+            <a:pPr indent="0" marL="0">
+              <a:buNone/>
+            </a:pPr>
+            <a:r>
+              <a:rPr lang="en-US" sz="2200" b="1" dirty="0">
+                <a:solidFill>
+                  <a:srgbClr val="1E2761"/>
+                </a:solidFill>
+                <a:latin typeface="Calibri" pitchFamily="34" charset="0"/>
+                <a:ea typeface="Calibri" pitchFamily="34" charset="-122"/>
+                <a:cs typeface="Calibri" pitchFamily="34" charset="-120"/>
+              </a:rPr>
+              <a:t>🖨️ Tom's padel grips</a:t>
+            </a:r>
+            <a:endParaRPr lang="en-US" sz="2200" dirty="0"/>
+          </a:p>
+        </p:txBody>
+      </p:sp>
+      <p:sp>
+        <p:nvSpPr>
+          <p:cNvPr id="5" name="Shape 3"/>
+          <p:cNvSpPr/>
+          <p:nvPr/>
+        </p:nvSpPr>
+        <p:spPr>
+          <a:xfrm>
+            <a:off x="3566160" y="1920240"/>
+            <a:ext cx="5029200" cy="3108960"/>
+          </a:xfrm>
+          <a:prstGeom prst="roundRect">
+            <a:avLst>
+              <a:gd name="adj" fmla="val 4118"/>
+            </a:avLst>
+          </a:prstGeom>
+          <a:solidFill>
+            <a:srgbClr val="F4F5F7"/>
+          </a:solidFill>
+          <a:ln/>
+        </p:spPr>
+      </p:sp>
+      <p:sp>
+        <p:nvSpPr>
+          <p:cNvPr id="6" name="Text 4"/>
+          <p:cNvSpPr/>
+          <p:nvPr/>
+        </p:nvSpPr>
+        <p:spPr>
+          <a:xfrm>
+            <a:off x="3840480" y="2194560"/>
+            <a:ext cx="4480560" cy="365760"/>
+          </a:xfrm>
+          <a:prstGeom prst="rect">
+            <a:avLst/>
+          </a:prstGeom>
+          <a:noFill/>
+          <a:ln/>
+        </p:spPr>
+        <p:txBody>
+          <a:bodyPr wrap="square" rtlCol="0" anchor="ctr"/>
+          <a:lstStyle/>
+          <a:p>
+            <a:pPr indent="0" marL="0">
+              <a:buNone/>
+            </a:pPr>
+            <a:r>
+              <a:rPr lang="en-US" sz="1400" b="1" dirty="0">
+                <a:solidFill>
+                  <a:srgbClr val="5B5B5B"/>
+                </a:solidFill>
+                <a:latin typeface="Calibri" pitchFamily="34" charset="0"/>
+                <a:ea typeface="Calibri" pitchFamily="34" charset="-122"/>
+                <a:cs typeface="Calibri" pitchFamily="34" charset="-120"/>
+              </a:rPr>
+              <a:t>Your turn — work it out</a:t>
+            </a:r>
+            <a:endParaRPr lang="en-US" sz="1400" dirty="0"/>
+          </a:p>
+        </p:txBody>
+      </p:sp>
+      <p:sp>
+        <p:nvSpPr>
+          <p:cNvPr id="7" name="Text 5"/>
+          <p:cNvSpPr/>
+          <p:nvPr/>
+        </p:nvSpPr>
+        <p:spPr>
+          <a:xfrm>
+            <a:off x="3840480" y="2651760"/>
+            <a:ext cx="4480560" cy="1280160"/>
+          </a:xfrm>
+          <a:prstGeom prst="rect">
+            <a:avLst/>
+          </a:prstGeom>
+          <a:noFill/>
+          <a:ln/>
+        </p:spPr>
+        <p:txBody>
+          <a:bodyPr wrap="square" rtlCol="0" anchor="t"/>
+          <a:lstStyle/>
+          <a:p>
+            <a:pPr indent="0" marL="0">
+              <a:spcAft>
+                <a:spcPts val="800"/>
+              </a:spcAft>
+              <a:buNone/>
+            </a:pPr>
+            <a:r>
+              <a:rPr lang="en-US" sz="1500" dirty="0">
+                <a:solidFill>
+                  <a:srgbClr val="1A1A1A"/>
+                </a:solidFill>
+                <a:latin typeface="Calibri" pitchFamily="34" charset="0"/>
+                <a:ea typeface="Calibri" pitchFamily="34" charset="-122"/>
+                <a:cs typeface="Calibri" pitchFamily="34" charset="-120"/>
+              </a:rPr>
+              <a:t>Price: $8 → $10</a:t>
+            </a:r>
+            <a:endParaRPr lang="en-US" sz="1500" dirty="0"/>
+          </a:p>
+          <a:p>
+            <a:pPr indent="0" marL="0">
+              <a:spcAft>
+                <a:spcPts val="800"/>
+              </a:spcAft>
+              <a:buNone/>
+            </a:pPr>
+            <a:r>
+              <a:rPr lang="en-US" sz="1500" dirty="0">
+                <a:solidFill>
+                  <a:srgbClr val="1A1A1A"/>
+                </a:solidFill>
+                <a:latin typeface="Calibri" pitchFamily="34" charset="0"/>
+                <a:ea typeface="Calibri" pitchFamily="34" charset="-122"/>
+                <a:cs typeface="Calibri" pitchFamily="34" charset="-120"/>
+              </a:rPr>
+              <a:t>Quantity: 60 → 54</a:t>
+            </a:r>
+            <a:endParaRPr lang="en-US" sz="1500" dirty="0"/>
+          </a:p>
+          <a:p>
+            <a:pPr indent="0" marL="0">
+              <a:spcAft>
+                <a:spcPts val="800"/>
+              </a:spcAft>
+              <a:buNone/>
+            </a:pPr>
+            <a:r>
+              <a:rPr lang="en-US" sz="1500" dirty="0">
+                <a:solidFill>
+                  <a:srgbClr val="1A1A1A"/>
+                </a:solidFill>
+                <a:latin typeface="Calibri" pitchFamily="34" charset="0"/>
+                <a:ea typeface="Calibri" pitchFamily="34" charset="-122"/>
+                <a:cs typeface="Calibri" pitchFamily="34" charset="-120"/>
+              </a:rPr>
+              <a:t>(PED = −0.4, from last lesson)</a:t>
+            </a:r>
+            <a:endParaRPr lang="en-US" sz="1500" dirty="0"/>
+          </a:p>
+        </p:txBody>
+      </p:sp>
+      <p:sp>
+        <p:nvSpPr>
+          <p:cNvPr id="8" name="Shape 6"/>
+          <p:cNvSpPr/>
+          <p:nvPr/>
+        </p:nvSpPr>
+        <p:spPr>
+          <a:xfrm>
+            <a:off x="3840480" y="4343400"/>
+            <a:ext cx="1828800" cy="0"/>
+          </a:xfrm>
+          <a:prstGeom prst="line">
+            <a:avLst/>
+          </a:prstGeom>
+          <a:noFill/>
+          <a:ln w="19050">
+            <a:solidFill>
+              <a:srgbClr val="5B5B5B"/>
+            </a:solidFill>
+            <a:prstDash val="solid"/>
+          </a:ln>
+        </p:spPr>
+      </p:sp>
+      <p:sp>
+        <p:nvSpPr>
+          <p:cNvPr id="9" name="Text 7"/>
+          <p:cNvSpPr/>
+          <p:nvPr/>
+        </p:nvSpPr>
+        <p:spPr>
+          <a:xfrm>
+            <a:off x="3840480" y="3977640"/>
+            <a:ext cx="4206240" cy="320040"/>
+          </a:xfrm>
+          <a:prstGeom prst="rect">
+            <a:avLst/>
+          </a:prstGeom>
+          <a:noFill/>
+          <a:ln/>
+        </p:spPr>
+        <p:txBody>
+          <a:bodyPr wrap="square" rtlCol="0" anchor="ctr"/>
+          <a:lstStyle/>
+          <a:p>
+            <a:pPr indent="0" marL="0">
+              <a:buNone/>
+            </a:pPr>
+            <a:r>
+              <a:rPr lang="en-US" sz="1400" dirty="0">
+                <a:solidFill>
+                  <a:srgbClr val="1A1A1A"/>
+                </a:solidFill>
+                <a:latin typeface="Calibri" pitchFamily="34" charset="0"/>
+                <a:ea typeface="Calibri" pitchFamily="34" charset="-122"/>
+                <a:cs typeface="Calibri" pitchFamily="34" charset="-120"/>
+              </a:rPr>
+              <a:t>TR before = $____</a:t>
+            </a:r>
+            <a:endParaRPr lang="en-US" sz="1400" dirty="0"/>
+          </a:p>
+        </p:txBody>
+      </p:sp>
+      <p:sp>
+        <p:nvSpPr>
+          <p:cNvPr id="10" name="Shape 8"/>
+          <p:cNvSpPr/>
+          <p:nvPr/>
+        </p:nvSpPr>
+        <p:spPr>
+          <a:xfrm>
+            <a:off x="3840480" y="4709160"/>
+            <a:ext cx="1828800" cy="0"/>
+          </a:xfrm>
+          <a:prstGeom prst="line">
+            <a:avLst/>
+          </a:prstGeom>
+          <a:noFill/>
+          <a:ln w="19050">
+            <a:solidFill>
+              <a:srgbClr val="5B5B5B"/>
+            </a:solidFill>
+            <a:prstDash val="solid"/>
+          </a:ln>
+        </p:spPr>
+      </p:sp>
+      <p:sp>
+        <p:nvSpPr>
+          <p:cNvPr id="11" name="Text 9"/>
+          <p:cNvSpPr/>
+          <p:nvPr/>
+        </p:nvSpPr>
+        <p:spPr>
+          <a:xfrm>
+            <a:off x="3840480" y="4343400"/>
+            <a:ext cx="4206240" cy="320040"/>
+          </a:xfrm>
+          <a:prstGeom prst="rect">
+            <a:avLst/>
+          </a:prstGeom>
+          <a:noFill/>
+          <a:ln/>
+        </p:spPr>
+        <p:txBody>
+          <a:bodyPr wrap="square" rtlCol="0" anchor="ctr"/>
+          <a:lstStyle/>
+          <a:p>
+            <a:pPr indent="0" marL="0">
+              <a:buNone/>
+            </a:pPr>
+            <a:r>
+              <a:rPr lang="en-US" sz="1400" dirty="0">
+                <a:solidFill>
+                  <a:srgbClr val="1A1A1A"/>
+                </a:solidFill>
+                <a:latin typeface="Calibri" pitchFamily="34" charset="0"/>
+                <a:ea typeface="Calibri" pitchFamily="34" charset="-122"/>
+                <a:cs typeface="Calibri" pitchFamily="34" charset="-120"/>
+              </a:rPr>
+              <a:t>TR after = $____</a:t>
+            </a:r>
+            <a:endParaRPr lang="en-US" sz="1400" dirty="0"/>
+          </a:p>
+        </p:txBody>
+      </p:sp>
+    </p:spTree>
+  </p:cSld>
+  <p:clrMapOvr>
+    <a:masterClrMapping/>
+  </p:clrMapOvr>
+</p:sld>
+</file>
+
+<file path=ppt/slides/slide15.xml><?xml version="1.0" encoding="utf-8"?>
+<p:sld xmlns:a="http://schemas.openxmlformats.org/drawingml/2006/main" xmlns:r="http://schemas.openxmlformats.org/officeDocument/2006/relationships" xmlns:p="http://schemas.openxmlformats.org/presentationml/2006/main">
+  <p:cSld name="Slide 15">
+    <p:bg>
+      <p:bgPr>
+        <a:solidFill>
+          <a:srgbClr val="FFFFFF"/>
+        </a:solidFill>
+      </p:bgPr>
+    </p:bg>
+    <p:spTree>
+      <p:nvGrpSpPr>
+        <p:cNvPr id="1" name=""/>
+        <p:cNvGrpSpPr/>
+        <p:nvPr/>
+      </p:nvGrpSpPr>
+      <p:grpSpPr>
+        <a:xfrm>
+          <a:off x="0" y="0"/>
+          <a:ext cx="0" cy="0"/>
+          <a:chOff x="0" y="0"/>
+          <a:chExt cx="0" cy="0"/>
+        </a:xfrm>
+      </p:grpSpPr>
+      <p:sp>
+        <p:nvSpPr>
+          <p:cNvPr id="2" name="Shape 0"/>
+          <p:cNvSpPr/>
+          <p:nvPr/>
+        </p:nvSpPr>
+        <p:spPr>
+          <a:xfrm>
+            <a:off x="640080" y="502920"/>
+            <a:ext cx="1325880" cy="365760"/>
+          </a:xfrm>
+          <a:prstGeom prst="roundRect">
+            <a:avLst>
+              <a:gd name="adj" fmla="val 50000"/>
+            </a:avLst>
+          </a:prstGeom>
+          <a:solidFill>
+            <a:srgbClr val="1BAF7A">
+              <a:alpha val="18000"/>
+            </a:srgbClr>
+          </a:solidFill>
+          <a:ln/>
+        </p:spPr>
+      </p:sp>
+      <p:sp>
+        <p:nvSpPr>
+          <p:cNvPr id="3" name="Text 1"/>
+          <p:cNvSpPr/>
+          <p:nvPr/>
+        </p:nvSpPr>
+        <p:spPr>
+          <a:xfrm>
+            <a:off x="640080" y="502920"/>
+            <a:ext cx="1325880" cy="365760"/>
+          </a:xfrm>
+          <a:prstGeom prst="rect">
+            <a:avLst/>
+          </a:prstGeom>
+          <a:noFill/>
+          <a:ln/>
+        </p:spPr>
+        <p:txBody>
+          <a:bodyPr wrap="square" rtlCol="0" anchor="ctr"/>
+          <a:lstStyle/>
+          <a:p>
+            <a:pPr algn="ctr" indent="0" marL="0">
+              <a:buNone/>
+            </a:pPr>
+            <a:r>
+              <a:rPr lang="en-US" sz="1200" b="1" dirty="0">
+                <a:solidFill>
+                  <a:srgbClr val="1BAF7A"/>
+                </a:solidFill>
+                <a:latin typeface="Calibri" pitchFamily="34" charset="0"/>
+                <a:ea typeface="Calibri" pitchFamily="34" charset="-122"/>
+                <a:cs typeface="Calibri" pitchFamily="34" charset="-120"/>
+              </a:rPr>
+              <a:t>✅ Revealed</a:t>
+            </a:r>
+            <a:endParaRPr lang="en-US" sz="1200" dirty="0"/>
+          </a:p>
+        </p:txBody>
+      </p:sp>
+      <p:sp>
+        <p:nvSpPr>
+          <p:cNvPr id="4" name="Text 2"/>
+          <p:cNvSpPr/>
+          <p:nvPr/>
+        </p:nvSpPr>
+        <p:spPr>
+          <a:xfrm>
+            <a:off x="640080" y="1051560"/>
+            <a:ext cx="10881360" cy="548640"/>
+          </a:xfrm>
+          <a:prstGeom prst="rect">
+            <a:avLst/>
+          </a:prstGeom>
+          <a:noFill/>
+          <a:ln/>
+        </p:spPr>
+        <p:txBody>
+          <a:bodyPr wrap="square" rtlCol="0" anchor="ctr"/>
+          <a:lstStyle/>
+          <a:p>
+            <a:pPr indent="0" marL="0">
+              <a:buNone/>
+            </a:pPr>
+            <a:r>
+              <a:rPr lang="en-US" sz="2200" b="1" dirty="0">
+                <a:solidFill>
+                  <a:srgbClr val="1E2761"/>
+                </a:solidFill>
+                <a:latin typeface="Calibri" pitchFamily="34" charset="0"/>
+                <a:ea typeface="Calibri" pitchFamily="34" charset="-122"/>
+                <a:cs typeface="Calibri" pitchFamily="34" charset="-120"/>
+              </a:rPr>
+              <a:t>🖨️ Tom's grips — answer</a:t>
+            </a:r>
+            <a:endParaRPr lang="en-US" sz="2200" dirty="0"/>
+          </a:p>
+        </p:txBody>
+      </p:sp>
+      <p:sp>
+        <p:nvSpPr>
+          <p:cNvPr id="5" name="Shape 3"/>
+          <p:cNvSpPr/>
+          <p:nvPr/>
+        </p:nvSpPr>
+        <p:spPr>
+          <a:xfrm>
+            <a:off x="3566160" y="1920240"/>
+            <a:ext cx="5029200" cy="3108960"/>
+          </a:xfrm>
+          <a:prstGeom prst="roundRect">
+            <a:avLst>
+              <a:gd name="adj" fmla="val 4118"/>
+            </a:avLst>
+          </a:prstGeom>
+          <a:solidFill>
+            <a:srgbClr val="F4F5F7"/>
+          </a:solidFill>
+          <a:ln/>
+        </p:spPr>
+      </p:sp>
+      <p:sp>
+        <p:nvSpPr>
+          <p:cNvPr id="6" name="Text 4"/>
+          <p:cNvSpPr/>
+          <p:nvPr/>
+        </p:nvSpPr>
+        <p:spPr>
+          <a:xfrm>
+            <a:off x="3840480" y="2194560"/>
+            <a:ext cx="4480560" cy="365760"/>
+          </a:xfrm>
+          <a:prstGeom prst="rect">
+            <a:avLst/>
+          </a:prstGeom>
+          <a:noFill/>
+          <a:ln/>
+        </p:spPr>
+        <p:txBody>
+          <a:bodyPr wrap="square" rtlCol="0" anchor="ctr"/>
+          <a:lstStyle/>
+          <a:p>
+            <a:pPr indent="0" marL="0">
+              <a:buNone/>
+            </a:pPr>
+            <a:r>
+              <a:rPr lang="en-US" sz="1400" b="1" dirty="0">
+                <a:solidFill>
+                  <a:srgbClr val="5B5B5B"/>
+                </a:solidFill>
+                <a:latin typeface="Calibri" pitchFamily="34" charset="0"/>
+                <a:ea typeface="Calibri" pitchFamily="34" charset="-122"/>
+                <a:cs typeface="Calibri" pitchFamily="34" charset="-120"/>
+              </a:rPr>
+              <a:t>Check your answer</a:t>
+            </a:r>
+            <a:endParaRPr lang="en-US" sz="1400" dirty="0"/>
+          </a:p>
+        </p:txBody>
+      </p:sp>
+      <p:sp>
+        <p:nvSpPr>
+          <p:cNvPr id="7" name="Text 5"/>
+          <p:cNvSpPr/>
+          <p:nvPr/>
+        </p:nvSpPr>
+        <p:spPr>
+          <a:xfrm>
+            <a:off x="3840480" y="2651760"/>
+            <a:ext cx="4480560" cy="1463040"/>
+          </a:xfrm>
+          <a:prstGeom prst="rect">
+            <a:avLst/>
+          </a:prstGeom>
+          <a:noFill/>
+          <a:ln/>
+        </p:spPr>
+        <p:txBody>
+          <a:bodyPr wrap="square" rtlCol="0" anchor="t"/>
+          <a:lstStyle/>
+          <a:p>
+            <a:pPr indent="0" marL="0">
+              <a:spcAft>
+                <a:spcPts val="600"/>
+              </a:spcAft>
+              <a:buNone/>
+            </a:pPr>
+            <a:r>
+              <a:rPr lang="en-US" sz="1500" dirty="0">
+                <a:solidFill>
+                  <a:srgbClr val="1A1A1A"/>
+                </a:solidFill>
+                <a:latin typeface="Calibri" pitchFamily="34" charset="0"/>
+                <a:ea typeface="Calibri" pitchFamily="34" charset="-122"/>
+                <a:cs typeface="Calibri" pitchFamily="34" charset="-120"/>
+              </a:rPr>
+              <a:t>TR before = $8 × 60 = $480</a:t>
+            </a:r>
+            <a:endParaRPr lang="en-US" sz="1500" dirty="0"/>
+          </a:p>
+          <a:p>
+            <a:pPr indent="0" marL="0">
+              <a:spcAft>
+                <a:spcPts val="600"/>
+              </a:spcAft>
+              <a:buNone/>
+            </a:pPr>
+            <a:r>
+              <a:rPr lang="en-US" sz="1500" dirty="0">
+                <a:solidFill>
+                  <a:srgbClr val="1A1A1A"/>
+                </a:solidFill>
+                <a:latin typeface="Calibri" pitchFamily="34" charset="0"/>
+                <a:ea typeface="Calibri" pitchFamily="34" charset="-122"/>
+                <a:cs typeface="Calibri" pitchFamily="34" charset="-120"/>
+              </a:rPr>
+              <a:t>TR after = $10 × 54 = $540</a:t>
+            </a:r>
+            <a:endParaRPr lang="en-US" sz="1500" dirty="0"/>
+          </a:p>
+        </p:txBody>
+      </p:sp>
+      <p:sp>
+        <p:nvSpPr>
+          <p:cNvPr id="8" name="Text 6"/>
+          <p:cNvSpPr/>
+          <p:nvPr/>
+        </p:nvSpPr>
+        <p:spPr>
+          <a:xfrm>
+            <a:off x="3840480" y="4206240"/>
+            <a:ext cx="4480560" cy="731520"/>
+          </a:xfrm>
+          <a:prstGeom prst="rect">
+            <a:avLst/>
+          </a:prstGeom>
+          <a:noFill/>
+          <a:ln/>
+        </p:spPr>
+        <p:txBody>
+          <a:bodyPr wrap="square" rtlCol="0" anchor="ctr"/>
+          <a:lstStyle/>
+          <a:p>
+            <a:pPr indent="0" marL="0">
+              <a:buNone/>
+            </a:pPr>
+            <a:r>
+              <a:rPr lang="en-US" sz="1800" b="1" dirty="0">
+                <a:solidFill>
+                  <a:srgbClr val="1BAF7A"/>
+                </a:solidFill>
+                <a:latin typeface="Cambria" pitchFamily="34" charset="0"/>
+                <a:ea typeface="Cambria" pitchFamily="34" charset="-122"/>
+                <a:cs typeface="Cambria" pitchFamily="34" charset="-120"/>
+              </a:rPr>
+              <a:t>Revenue rose — inelastic, again</a:t>
+            </a:r>
+            <a:endParaRPr lang="en-US" sz="1800" dirty="0"/>
+          </a:p>
+        </p:txBody>
+      </p:sp>
+    </p:spTree>
+  </p:cSld>
+  <p:clrMapOvr>
+    <a:masterClrMapping/>
+  </p:clrMapOvr>
+</p:sld>
+</file>
+
+<file path=ppt/slides/slide16.xml><?xml version="1.0" encoding="utf-8"?>
+<p:sld xmlns:a="http://schemas.openxmlformats.org/drawingml/2006/main" xmlns:r="http://schemas.openxmlformats.org/officeDocument/2006/relationships" xmlns:p="http://schemas.openxmlformats.org/presentationml/2006/main">
+  <p:cSld name="Slide 16">
+    <p:bg>
+      <p:bgPr>
+        <a:solidFill>
+          <a:srgbClr val="FFFFFF"/>
+        </a:solidFill>
+      </p:bgPr>
+    </p:bg>
+    <p:spTree>
+      <p:nvGrpSpPr>
+        <p:cNvPr id="1" name=""/>
+        <p:cNvGrpSpPr/>
+        <p:nvPr/>
+      </p:nvGrpSpPr>
+      <p:grpSpPr>
+        <a:xfrm>
+          <a:off x="0" y="0"/>
+          <a:ext cx="0" cy="0"/>
+          <a:chOff x="0" y="0"/>
+          <a:chExt cx="0" cy="0"/>
+        </a:xfrm>
+      </p:grpSpPr>
+      <p:sp>
+        <p:nvSpPr>
+          <p:cNvPr id="2" name="Text 0"/>
+          <p:cNvSpPr/>
+          <p:nvPr/>
+        </p:nvSpPr>
+        <p:spPr>
+          <a:xfrm>
+            <a:off x="640080" y="548640"/>
+            <a:ext cx="10881360" cy="731520"/>
+          </a:xfrm>
+          <a:prstGeom prst="rect">
+            <a:avLst/>
+          </a:prstGeom>
+          <a:noFill/>
+          <a:ln/>
+        </p:spPr>
+        <p:txBody>
+          <a:bodyPr wrap="square" rtlCol="0" anchor="ctr"/>
+          <a:lstStyle/>
+          <a:p>
+            <a:pPr indent="0" marL="0">
+              <a:buNone/>
+            </a:pPr>
+            <a:r>
+              <a:rPr lang="en-US" sz="3200" b="1" dirty="0">
+                <a:solidFill>
+                  <a:srgbClr val="1E2761"/>
+                </a:solidFill>
+                <a:latin typeface="Cambria" pitchFamily="34" charset="0"/>
+                <a:ea typeface="Cambria" pitchFamily="34" charset="-122"/>
+                <a:cs typeface="Cambria" pitchFamily="34" charset="-120"/>
+              </a:rPr>
               <a:t>The rule</a:t>
             </a:r>
             <a:endParaRPr lang="en-US" sz="3200" dirty="0"/>
@@ -3097,7 +4677,7 @@
       </p:sp>
       <p:graphicFrame>
         <p:nvGraphicFramePr>
-          <p:cNvPr id="13" name="Table 0"/>
+          <p:cNvPr id="17" name="Table 0"/>
           <p:cNvGraphicFramePr>
             <a:graphicFrameLocks noGrp="1"/>
           </p:cNvGraphicFramePr>
@@ -3958,9 +5538,9 @@
 </p:sld>
 </file>
 
-<file path=ppt/slides/slide13.xml><?xml version="1.0" encoding="utf-8"?>
+<file path=ppt/slides/slide17.xml><?xml version="1.0" encoding="utf-8"?>
 <p:sld xmlns:a="http://schemas.openxmlformats.org/drawingml/2006/main" xmlns:r="http://schemas.openxmlformats.org/officeDocument/2006/relationships" xmlns:p="http://schemas.openxmlformats.org/presentationml/2006/main">
-  <p:cSld name="Slide 13">
+  <p:cSld name="Slide 17">
     <p:bg>
       <p:bgPr>
         <a:solidFill>
@@ -4338,9 +5918,9 @@
 </p:sld>
 </file>
 
-<file path=ppt/slides/slide14.xml><?xml version="1.0" encoding="utf-8"?>
+<file path=ppt/slides/slide18.xml><?xml version="1.0" encoding="utf-8"?>
 <p:sld xmlns:a="http://schemas.openxmlformats.org/drawingml/2006/main" xmlns:r="http://schemas.openxmlformats.org/officeDocument/2006/relationships" xmlns:p="http://schemas.openxmlformats.org/presentationml/2006/main">
-  <p:cSld name="Slide 14">
+  <p:cSld name="Slide 18">
     <p:bg>
       <p:bgPr>
         <a:solidFill>
@@ -4477,9 +6057,9 @@
 </p:sld>
 </file>
 
-<file path=ppt/slides/slide15.xml><?xml version="1.0" encoding="utf-8"?>
+<file path=ppt/slides/slide19.xml><?xml version="1.0" encoding="utf-8"?>
 <p:sld xmlns:a="http://schemas.openxmlformats.org/drawingml/2006/main" xmlns:r="http://schemas.openxmlformats.org/officeDocument/2006/relationships" xmlns:p="http://schemas.openxmlformats.org/presentationml/2006/main">
-  <p:cSld name="Slide 15">
+  <p:cSld name="Slide 19">
     <p:bg>
       <p:bgPr>
         <a:solidFill>
@@ -4649,155 +6229,6 @@
                 <a:cs typeface="Calibri" pitchFamily="34" charset="-120"/>
               </a:rPr>
               <a:t>That's why PED matters to firms' pricing, consumers' budgets, and government tax choices.</a:t>
-            </a:r>
-            <a:endParaRPr lang="en-US" sz="1800" dirty="0"/>
-          </a:p>
-        </p:txBody>
-      </p:sp>
-    </p:spTree>
-  </p:cSld>
-  <p:clrMapOvr>
-    <a:masterClrMapping/>
-  </p:clrMapOvr>
-</p:sld>
-</file>
-
-<file path=ppt/slides/slide16.xml><?xml version="1.0" encoding="utf-8"?>
-<p:sld xmlns:a="http://schemas.openxmlformats.org/drawingml/2006/main" xmlns:r="http://schemas.openxmlformats.org/officeDocument/2006/relationships" xmlns:p="http://schemas.openxmlformats.org/presentationml/2006/main">
-  <p:cSld name="Slide 16">
-    <p:bg>
-      <p:bgPr>
-        <a:solidFill>
-          <a:srgbClr val="1E2761"/>
-        </a:solidFill>
-      </p:bgPr>
-    </p:bg>
-    <p:spTree>
-      <p:nvGrpSpPr>
-        <p:cNvPr id="1" name=""/>
-        <p:cNvGrpSpPr/>
-        <p:nvPr/>
-      </p:nvGrpSpPr>
-      <p:grpSpPr>
-        <a:xfrm>
-          <a:off x="0" y="0"/>
-          <a:ext cx="0" cy="0"/>
-          <a:chOff x="0" y="0"/>
-          <a:chExt cx="0" cy="0"/>
-        </a:xfrm>
-      </p:grpSpPr>
-      <p:sp>
-        <p:nvSpPr>
-          <p:cNvPr id="2" name="Text 0"/>
-          <p:cNvSpPr/>
-          <p:nvPr/>
-        </p:nvSpPr>
-        <p:spPr>
-          <a:xfrm>
-            <a:off x="640080" y="2103120"/>
-            <a:ext cx="10881360" cy="457200"/>
-          </a:xfrm>
-          <a:prstGeom prst="rect">
-            <a:avLst/>
-          </a:prstGeom>
-          <a:noFill/>
-          <a:ln/>
-        </p:spPr>
-        <p:txBody>
-          <a:bodyPr wrap="square" rtlCol="0" anchor="ctr"/>
-          <a:lstStyle/>
-          <a:p>
-            <a:pPr indent="0" marL="0">
-              <a:buNone/>
-            </a:pPr>
-            <a:r>
-              <a:rPr lang="en-US" sz="1400" b="1" spc="200" kern="0" dirty="0">
-                <a:solidFill>
-                  <a:srgbClr val="CADCFC"/>
-                </a:solidFill>
-                <a:latin typeface="Calibri" pitchFamily="34" charset="0"/>
-                <a:ea typeface="Calibri" pitchFamily="34" charset="-122"/>
-                <a:cs typeface="Calibri" pitchFamily="34" charset="-120"/>
-              </a:rPr>
-              <a:t>NEXT LESSON</a:t>
-            </a:r>
-            <a:endParaRPr lang="en-US" sz="1400" dirty="0"/>
-          </a:p>
-        </p:txBody>
-      </p:sp>
-      <p:sp>
-        <p:nvSpPr>
-          <p:cNvPr id="3" name="Text 1"/>
-          <p:cNvSpPr/>
-          <p:nvPr/>
-        </p:nvSpPr>
-        <p:spPr>
-          <a:xfrm>
-            <a:off x="640080" y="2560320"/>
-            <a:ext cx="10881360" cy="1463040"/>
-          </a:xfrm>
-          <a:prstGeom prst="rect">
-            <a:avLst/>
-          </a:prstGeom>
-          <a:noFill/>
-          <a:ln/>
-        </p:spPr>
-        <p:txBody>
-          <a:bodyPr wrap="square" rtlCol="0" anchor="ctr"/>
-          <a:lstStyle/>
-          <a:p>
-            <a:pPr indent="0" marL="0">
-              <a:buNone/>
-            </a:pPr>
-            <a:r>
-              <a:rPr lang="en-US" sz="4400" b="1" dirty="0">
-                <a:solidFill>
-                  <a:srgbClr val="FFFFFF"/>
-                </a:solidFill>
-                <a:latin typeface="Cambria" pitchFamily="34" charset="0"/>
-                <a:ea typeface="Cambria" pitchFamily="34" charset="-122"/>
-                <a:cs typeface="Cambria" pitchFamily="34" charset="-120"/>
-              </a:rPr>
-              <a:t>Price elasticity of supply (PES)</a:t>
-            </a:r>
-            <a:endParaRPr lang="en-US" sz="4400" dirty="0"/>
-          </a:p>
-        </p:txBody>
-      </p:sp>
-      <p:sp>
-        <p:nvSpPr>
-          <p:cNvPr id="4" name="Text 2"/>
-          <p:cNvSpPr/>
-          <p:nvPr/>
-        </p:nvSpPr>
-        <p:spPr>
-          <a:xfrm>
-            <a:off x="640080" y="3931920"/>
-            <a:ext cx="9601200" cy="731520"/>
-          </a:xfrm>
-          <a:prstGeom prst="rect">
-            <a:avLst/>
-          </a:prstGeom>
-          <a:noFill/>
-          <a:ln/>
-        </p:spPr>
-        <p:txBody>
-          <a:bodyPr wrap="square" rtlCol="0" anchor="ctr"/>
-          <a:lstStyle/>
-          <a:p>
-            <a:pPr indent="0" marL="0">
-              <a:buNone/>
-            </a:pPr>
-            <a:r>
-              <a:rPr lang="en-US" sz="1800" dirty="0">
-                <a:solidFill>
-                  <a:srgbClr val="CADCFC"/>
-                </a:solidFill>
-                <a:latin typeface="Calibri" pitchFamily="34" charset="0"/>
-                <a:ea typeface="Calibri" pitchFamily="34" charset="-122"/>
-                <a:cs typeface="Calibri" pitchFamily="34" charset="-120"/>
-              </a:rPr>
-              <a:t>Same structure, new letter — how responsive is quantity supplied to a price change?</a:t>
             </a:r>
             <a:endParaRPr lang="en-US" sz="1800" dirty="0"/>
           </a:p>
@@ -4984,6 +6415,155 @@
 </p:sld>
 </file>
 
+<file path=ppt/slides/slide20.xml><?xml version="1.0" encoding="utf-8"?>
+<p:sld xmlns:a="http://schemas.openxmlformats.org/drawingml/2006/main" xmlns:r="http://schemas.openxmlformats.org/officeDocument/2006/relationships" xmlns:p="http://schemas.openxmlformats.org/presentationml/2006/main">
+  <p:cSld name="Slide 20">
+    <p:bg>
+      <p:bgPr>
+        <a:solidFill>
+          <a:srgbClr val="1E2761"/>
+        </a:solidFill>
+      </p:bgPr>
+    </p:bg>
+    <p:spTree>
+      <p:nvGrpSpPr>
+        <p:cNvPr id="1" name=""/>
+        <p:cNvGrpSpPr/>
+        <p:nvPr/>
+      </p:nvGrpSpPr>
+      <p:grpSpPr>
+        <a:xfrm>
+          <a:off x="0" y="0"/>
+          <a:ext cx="0" cy="0"/>
+          <a:chOff x="0" y="0"/>
+          <a:chExt cx="0" cy="0"/>
+        </a:xfrm>
+      </p:grpSpPr>
+      <p:sp>
+        <p:nvSpPr>
+          <p:cNvPr id="2" name="Text 0"/>
+          <p:cNvSpPr/>
+          <p:nvPr/>
+        </p:nvSpPr>
+        <p:spPr>
+          <a:xfrm>
+            <a:off x="640080" y="2103120"/>
+            <a:ext cx="10881360" cy="457200"/>
+          </a:xfrm>
+          <a:prstGeom prst="rect">
+            <a:avLst/>
+          </a:prstGeom>
+          <a:noFill/>
+          <a:ln/>
+        </p:spPr>
+        <p:txBody>
+          <a:bodyPr wrap="square" rtlCol="0" anchor="ctr"/>
+          <a:lstStyle/>
+          <a:p>
+            <a:pPr indent="0" marL="0">
+              <a:buNone/>
+            </a:pPr>
+            <a:r>
+              <a:rPr lang="en-US" sz="1400" b="1" spc="200" kern="0" dirty="0">
+                <a:solidFill>
+                  <a:srgbClr val="CADCFC"/>
+                </a:solidFill>
+                <a:latin typeface="Calibri" pitchFamily="34" charset="0"/>
+                <a:ea typeface="Calibri" pitchFamily="34" charset="-122"/>
+                <a:cs typeface="Calibri" pitchFamily="34" charset="-120"/>
+              </a:rPr>
+              <a:t>NEXT LESSON</a:t>
+            </a:r>
+            <a:endParaRPr lang="en-US" sz="1400" dirty="0"/>
+          </a:p>
+        </p:txBody>
+      </p:sp>
+      <p:sp>
+        <p:nvSpPr>
+          <p:cNvPr id="3" name="Text 1"/>
+          <p:cNvSpPr/>
+          <p:nvPr/>
+        </p:nvSpPr>
+        <p:spPr>
+          <a:xfrm>
+            <a:off x="640080" y="2560320"/>
+            <a:ext cx="10881360" cy="1463040"/>
+          </a:xfrm>
+          <a:prstGeom prst="rect">
+            <a:avLst/>
+          </a:prstGeom>
+          <a:noFill/>
+          <a:ln/>
+        </p:spPr>
+        <p:txBody>
+          <a:bodyPr wrap="square" rtlCol="0" anchor="ctr"/>
+          <a:lstStyle/>
+          <a:p>
+            <a:pPr indent="0" marL="0">
+              <a:buNone/>
+            </a:pPr>
+            <a:r>
+              <a:rPr lang="en-US" sz="4400" b="1" dirty="0">
+                <a:solidFill>
+                  <a:srgbClr val="FFFFFF"/>
+                </a:solidFill>
+                <a:latin typeface="Cambria" pitchFamily="34" charset="0"/>
+                <a:ea typeface="Cambria" pitchFamily="34" charset="-122"/>
+                <a:cs typeface="Cambria" pitchFamily="34" charset="-120"/>
+              </a:rPr>
+              <a:t>Price elasticity of supply (PES)</a:t>
+            </a:r>
+            <a:endParaRPr lang="en-US" sz="4400" dirty="0"/>
+          </a:p>
+        </p:txBody>
+      </p:sp>
+      <p:sp>
+        <p:nvSpPr>
+          <p:cNvPr id="4" name="Text 2"/>
+          <p:cNvSpPr/>
+          <p:nvPr/>
+        </p:nvSpPr>
+        <p:spPr>
+          <a:xfrm>
+            <a:off x="640080" y="3931920"/>
+            <a:ext cx="9601200" cy="731520"/>
+          </a:xfrm>
+          <a:prstGeom prst="rect">
+            <a:avLst/>
+          </a:prstGeom>
+          <a:noFill/>
+          <a:ln/>
+        </p:spPr>
+        <p:txBody>
+          <a:bodyPr wrap="square" rtlCol="0" anchor="ctr"/>
+          <a:lstStyle/>
+          <a:p>
+            <a:pPr indent="0" marL="0">
+              <a:buNone/>
+            </a:pPr>
+            <a:r>
+              <a:rPr lang="en-US" sz="1800" dirty="0">
+                <a:solidFill>
+                  <a:srgbClr val="CADCFC"/>
+                </a:solidFill>
+                <a:latin typeface="Calibri" pitchFamily="34" charset="0"/>
+                <a:ea typeface="Calibri" pitchFamily="34" charset="-122"/>
+                <a:cs typeface="Calibri" pitchFamily="34" charset="-120"/>
+              </a:rPr>
+              <a:t>Same structure, new letter — how responsive is quantity supplied to a price change?</a:t>
+            </a:r>
+            <a:endParaRPr lang="en-US" sz="1800" dirty="0"/>
+          </a:p>
+        </p:txBody>
+      </p:sp>
+    </p:spTree>
+  </p:cSld>
+  <p:clrMapOvr>
+    <a:masterClrMapping/>
+  </p:clrMapOvr>
+</p:sld>
+</file>
+
 <file path=ppt/slides/slide3.xml><?xml version="1.0" encoding="utf-8"?>
 <p:sld xmlns:a="http://schemas.openxmlformats.org/drawingml/2006/main" xmlns:r="http://schemas.openxmlformats.org/officeDocument/2006/relationships" xmlns:p="http://schemas.openxmlformats.org/presentationml/2006/main">
   <p:cSld name="Slide 3">
@@ -5189,8 +6769,8 @@
         </p:nvSpPr>
         <p:spPr>
           <a:xfrm>
-            <a:off x="640080" y="548640"/>
-            <a:ext cx="10881360" cy="822960"/>
+            <a:off x="640080" y="640080"/>
+            <a:ext cx="10881360" cy="731520"/>
           </a:xfrm>
           <a:prstGeom prst="rect">
             <a:avLst/>
@@ -5206,7 +6786,7 @@
               <a:buNone/>
             </a:pPr>
             <a:r>
-              <a:rPr lang="en-US" sz="3200" b="1" dirty="0">
+              <a:rPr lang="en-US" sz="3000" b="1" dirty="0">
                 <a:solidFill>
                   <a:srgbClr val="1E2761"/>
                 </a:solidFill>
@@ -5214,22 +6794,44 @@
                 <a:ea typeface="Cambria" pitchFamily="34" charset="-122"/>
                 <a:cs typeface="Cambria" pitchFamily="34" charset="-120"/>
               </a:rPr>
-              <a:t>Today's real question</a:t>
-            </a:r>
-            <a:endParaRPr lang="en-US" sz="3200" dirty="0"/>
-          </a:p>
-        </p:txBody>
-      </p:sp>
-      <p:sp>
-        <p:nvSpPr>
-          <p:cNvPr id="3" name="Text 1"/>
-          <p:cNvSpPr/>
-          <p:nvPr/>
-        </p:nvSpPr>
-        <p:spPr>
-          <a:xfrm>
-            <a:off x="822960" y="1828800"/>
-            <a:ext cx="9875520" cy="4114800"/>
+              <a:t>Quick PED refresher</a:t>
+            </a:r>
+            <a:endParaRPr lang="en-US" sz="3000" dirty="0"/>
+          </a:p>
+        </p:txBody>
+      </p:sp>
+      <p:sp>
+        <p:nvSpPr>
+          <p:cNvPr id="3" name="Shape 1"/>
+          <p:cNvSpPr/>
+          <p:nvPr/>
+        </p:nvSpPr>
+        <p:spPr>
+          <a:xfrm>
+            <a:off x="2651760" y="1645920"/>
+            <a:ext cx="6858000" cy="1188720"/>
+          </a:xfrm>
+          <a:prstGeom prst="roundRect">
+            <a:avLst>
+              <a:gd name="adj" fmla="val 10769"/>
+            </a:avLst>
+          </a:prstGeom>
+          <a:solidFill>
+            <a:srgbClr val="1E2761"/>
+          </a:solidFill>
+          <a:ln/>
+        </p:spPr>
+      </p:sp>
+      <p:sp>
+        <p:nvSpPr>
+          <p:cNvPr id="4" name="Text 2"/>
+          <p:cNvSpPr/>
+          <p:nvPr/>
+        </p:nvSpPr>
+        <p:spPr>
+          <a:xfrm>
+            <a:off x="2651760" y="1645920"/>
+            <a:ext cx="6858000" cy="1188720"/>
           </a:xfrm>
           <a:prstGeom prst="rect">
             <a:avLst/>
@@ -5238,20 +6840,53 @@
           <a:ln/>
         </p:spPr>
         <p:txBody>
-          <a:bodyPr wrap="square" rtlCol="0" anchor="t"/>
+          <a:bodyPr wrap="square" rtlCol="0" anchor="ctr"/>
+          <a:lstStyle/>
+          <a:p>
+            <a:pPr algn="ctr" indent="0" marL="0">
+              <a:buNone/>
+            </a:pPr>
+            <a:r>
+              <a:rPr lang="en-US" sz="3000" b="1" dirty="0">
+                <a:solidFill>
+                  <a:srgbClr val="CADCFC"/>
+                </a:solidFill>
+                <a:latin typeface="Cambria" pitchFamily="34" charset="0"/>
+                <a:ea typeface="Cambria" pitchFamily="34" charset="-122"/>
+                <a:cs typeface="Cambria" pitchFamily="34" charset="-120"/>
+              </a:rPr>
+              <a:t>PED = %ΔQd ÷ %ΔP</a:t>
+            </a:r>
+            <a:endParaRPr lang="en-US" sz="3000" dirty="0"/>
+          </a:p>
+        </p:txBody>
+      </p:sp>
+      <p:sp>
+        <p:nvSpPr>
+          <p:cNvPr id="5" name="Text 3"/>
+          <p:cNvSpPr/>
+          <p:nvPr/>
+        </p:nvSpPr>
+        <p:spPr>
+          <a:xfrm>
+            <a:off x="822960" y="3108960"/>
+            <a:ext cx="9601200" cy="914400"/>
+          </a:xfrm>
+          <a:prstGeom prst="rect">
+            <a:avLst/>
+          </a:prstGeom>
+          <a:noFill/>
+          <a:ln/>
+        </p:spPr>
+        <p:txBody>
+          <a:bodyPr wrap="square" rtlCol="0" anchor="ctr"/>
           <a:lstStyle/>
           <a:p>
             <a:pPr indent="0" marL="0">
-              <a:lnSpc>
-                <a:spcPct val="130000"/>
-              </a:lnSpc>
-              <a:spcAft>
-                <a:spcPts val="1400"/>
-              </a:spcAft>
-              <a:buNone/>
-            </a:pPr>
-            <a:r>
-              <a:rPr lang="en-US" sz="1800" dirty="0">
+              <a:buNone/>
+            </a:pPr>
+            <a:r>
+              <a:rPr lang="en-US" sz="1600" dirty="0">
                 <a:solidFill>
                   <a:srgbClr val="1A1A1A"/>
                 </a:solidFill>
@@ -5259,55 +6894,9 @@
                 <a:ea typeface="Calibri" pitchFamily="34" charset="-122"/>
                 <a:cs typeface="Calibri" pitchFamily="34" charset="-120"/>
               </a:rPr>
-              <a:t>Tom puts up the price of his padel grips.</a:t>
-            </a:r>
-            <a:endParaRPr lang="en-US" sz="1800" dirty="0"/>
-          </a:p>
-          <a:p>
-            <a:pPr indent="0" marL="0">
-              <a:lnSpc>
-                <a:spcPct val="130000"/>
-              </a:lnSpc>
-              <a:spcAft>
-                <a:spcPts val="1400"/>
-              </a:spcAft>
-              <a:buNone/>
-            </a:pPr>
-            <a:r>
-              <a:rPr lang="en-US" sz="1800" dirty="0">
-                <a:solidFill>
-                  <a:srgbClr val="1A1A1A"/>
-                </a:solidFill>
-                <a:latin typeface="Calibri" pitchFamily="34" charset="0"/>
-                <a:ea typeface="Calibri" pitchFamily="34" charset="-122"/>
-                <a:cs typeface="Calibri" pitchFamily="34" charset="-120"/>
-              </a:rPr>
-              <a:t>More money per grip sold... but does he end up with more total money?</a:t>
-            </a:r>
-            <a:endParaRPr lang="en-US" sz="1800" dirty="0"/>
-          </a:p>
-          <a:p>
-            <a:pPr indent="0" marL="0">
-              <a:lnSpc>
-                <a:spcPct val="130000"/>
-              </a:lnSpc>
-              <a:spcAft>
-                <a:spcPts val="1400"/>
-              </a:spcAft>
-              <a:buNone/>
-            </a:pPr>
-            <a:r>
-              <a:rPr lang="en-US" sz="1800" dirty="0">
-                <a:solidFill>
-                  <a:srgbClr val="1A1A1A"/>
-                </a:solidFill>
-                <a:latin typeface="Calibri" pitchFamily="34" charset="0"/>
-                <a:ea typeface="Calibri" pitchFamily="34" charset="-122"/>
-                <a:cs typeface="Calibri" pitchFamily="34" charset="-120"/>
-              </a:rPr>
-              <a:t>Guess — and tell me why.</a:t>
-            </a:r>
-            <a:endParaRPr lang="en-US" sz="1800" dirty="0"/>
+              <a:t>Size &lt; 1 = inelastic. Size &gt; 1 = elastic. Size = 1 = unitary. Let's get a few reps in before we look at revenue.</a:t>
+            </a:r>
+            <a:endParaRPr lang="en-US" sz="1600" dirty="0"/>
           </a:p>
         </p:txBody>
       </p:sp>
@@ -5345,14 +6934,38 @@
       </p:grpSpPr>
       <p:sp>
         <p:nvSpPr>
-          <p:cNvPr id="2" name="Text 0"/>
-          <p:cNvSpPr/>
-          <p:nvPr/>
-        </p:nvSpPr>
-        <p:spPr>
-          <a:xfrm>
-            <a:off x="640080" y="640080"/>
-            <a:ext cx="10881360" cy="731520"/>
+          <p:cNvPr id="2" name="Shape 0"/>
+          <p:cNvSpPr/>
+          <p:nvPr/>
+        </p:nvSpPr>
+        <p:spPr>
+          <a:xfrm>
+            <a:off x="640080" y="502920"/>
+            <a:ext cx="1426464" cy="365760"/>
+          </a:xfrm>
+          <a:prstGeom prst="roundRect">
+            <a:avLst>
+              <a:gd name="adj" fmla="val 50000"/>
+            </a:avLst>
+          </a:prstGeom>
+          <a:solidFill>
+            <a:srgbClr val="F96167">
+              <a:alpha val="18000"/>
+            </a:srgbClr>
+          </a:solidFill>
+          <a:ln/>
+        </p:spPr>
+      </p:sp>
+      <p:sp>
+        <p:nvSpPr>
+          <p:cNvPr id="3" name="Text 1"/>
+          <p:cNvSpPr/>
+          <p:nvPr/>
+        </p:nvSpPr>
+        <p:spPr>
+          <a:xfrm>
+            <a:off x="640080" y="502920"/>
+            <a:ext cx="1426464" cy="365760"/>
           </a:xfrm>
           <a:prstGeom prst="rect">
             <a:avLst/>
@@ -5364,11 +6977,212 @@
           <a:bodyPr wrap="square" rtlCol="0" anchor="ctr"/>
           <a:lstStyle/>
           <a:p>
+            <a:pPr algn="ctr" indent="0" marL="0">
+              <a:buNone/>
+            </a:pPr>
+            <a:r>
+              <a:rPr lang="en-US" sz="1200" b="1" dirty="0">
+                <a:solidFill>
+                  <a:srgbClr val="F96167"/>
+                </a:solidFill>
+                <a:latin typeface="Calibri" pitchFamily="34" charset="0"/>
+                <a:ea typeface="Calibri" pitchFamily="34" charset="-122"/>
+                <a:cs typeface="Calibri" pitchFamily="34" charset="-120"/>
+              </a:rPr>
+              <a:t>✍️ Practice</a:t>
+            </a:r>
+            <a:endParaRPr lang="en-US" sz="1200" dirty="0"/>
+          </a:p>
+        </p:txBody>
+      </p:sp>
+      <p:sp>
+        <p:nvSpPr>
+          <p:cNvPr id="4" name="Text 2"/>
+          <p:cNvSpPr/>
+          <p:nvPr/>
+        </p:nvSpPr>
+        <p:spPr>
+          <a:xfrm>
+            <a:off x="640080" y="1051560"/>
+            <a:ext cx="10881360" cy="548640"/>
+          </a:xfrm>
+          <a:prstGeom prst="rect">
+            <a:avLst/>
+          </a:prstGeom>
+          <a:noFill/>
+          <a:ln/>
+        </p:spPr>
+        <p:txBody>
+          <a:bodyPr wrap="square" rtlCol="0" anchor="ctr"/>
+          <a:lstStyle/>
+          <a:p>
             <a:pPr indent="0" marL="0">
               <a:buNone/>
             </a:pPr>
             <a:r>
-              <a:rPr lang="en-US" sz="3000" b="1" dirty="0">
+              <a:rPr lang="en-US" sz="2200" b="1" dirty="0">
+                <a:solidFill>
+                  <a:srgbClr val="1E2761"/>
+                </a:solidFill>
+                <a:latin typeface="Calibri" pitchFamily="34" charset="0"/>
+                <a:ea typeface="Calibri" pitchFamily="34" charset="-122"/>
+                <a:cs typeface="Calibri" pitchFamily="34" charset="-120"/>
+              </a:rPr>
+              <a:t>🎾 Racket restring service</a:t>
+            </a:r>
+            <a:endParaRPr lang="en-US" sz="2200" dirty="0"/>
+          </a:p>
+        </p:txBody>
+      </p:sp>
+      <p:sp>
+        <p:nvSpPr>
+          <p:cNvPr id="5" name="Shape 3"/>
+          <p:cNvSpPr/>
+          <p:nvPr/>
+        </p:nvSpPr>
+        <p:spPr>
+          <a:xfrm>
+            <a:off x="3566160" y="1920240"/>
+            <a:ext cx="5029200" cy="3108960"/>
+          </a:xfrm>
+          <a:prstGeom prst="roundRect">
+            <a:avLst>
+              <a:gd name="adj" fmla="val 4118"/>
+            </a:avLst>
+          </a:prstGeom>
+          <a:solidFill>
+            <a:srgbClr val="F4F5F7"/>
+          </a:solidFill>
+          <a:ln/>
+        </p:spPr>
+      </p:sp>
+      <p:sp>
+        <p:nvSpPr>
+          <p:cNvPr id="6" name="Text 4"/>
+          <p:cNvSpPr/>
+          <p:nvPr/>
+        </p:nvSpPr>
+        <p:spPr>
+          <a:xfrm>
+            <a:off x="3840480" y="2194560"/>
+            <a:ext cx="4480560" cy="365760"/>
+          </a:xfrm>
+          <a:prstGeom prst="rect">
+            <a:avLst/>
+          </a:prstGeom>
+          <a:noFill/>
+          <a:ln/>
+        </p:spPr>
+        <p:txBody>
+          <a:bodyPr wrap="square" rtlCol="0" anchor="ctr"/>
+          <a:lstStyle/>
+          <a:p>
+            <a:pPr indent="0" marL="0">
+              <a:buNone/>
+            </a:pPr>
+            <a:r>
+              <a:rPr lang="en-US" sz="1400" b="1" dirty="0">
+                <a:solidFill>
+                  <a:srgbClr val="5B5B5B"/>
+                </a:solidFill>
+                <a:latin typeface="Calibri" pitchFamily="34" charset="0"/>
+                <a:ea typeface="Calibri" pitchFamily="34" charset="-122"/>
+                <a:cs typeface="Calibri" pitchFamily="34" charset="-120"/>
+              </a:rPr>
+              <a:t>Practice: calculate the PED</a:t>
+            </a:r>
+            <a:endParaRPr lang="en-US" sz="1400" dirty="0"/>
+          </a:p>
+        </p:txBody>
+      </p:sp>
+      <p:sp>
+        <p:nvSpPr>
+          <p:cNvPr id="7" name="Text 5"/>
+          <p:cNvSpPr/>
+          <p:nvPr/>
+        </p:nvSpPr>
+        <p:spPr>
+          <a:xfrm>
+            <a:off x="3840480" y="2651760"/>
+            <a:ext cx="4480560" cy="1463040"/>
+          </a:xfrm>
+          <a:prstGeom prst="rect">
+            <a:avLst/>
+          </a:prstGeom>
+          <a:noFill/>
+          <a:ln/>
+        </p:spPr>
+        <p:txBody>
+          <a:bodyPr wrap="square" rtlCol="0" anchor="t"/>
+          <a:lstStyle/>
+          <a:p>
+            <a:pPr indent="0" marL="0">
+              <a:spcAft>
+                <a:spcPts val="600"/>
+              </a:spcAft>
+              <a:buNone/>
+            </a:pPr>
+            <a:r>
+              <a:rPr lang="en-US" sz="1500" dirty="0">
+                <a:solidFill>
+                  <a:srgbClr val="1A1A1A"/>
+                </a:solidFill>
+                <a:latin typeface="Calibri" pitchFamily="34" charset="0"/>
+                <a:ea typeface="Calibri" pitchFamily="34" charset="-122"/>
+                <a:cs typeface="Calibri" pitchFamily="34" charset="-120"/>
+              </a:rPr>
+              <a:t>Price: $15 → $18  (+20%)</a:t>
+            </a:r>
+            <a:endParaRPr lang="en-US" sz="1500" dirty="0"/>
+          </a:p>
+          <a:p>
+            <a:pPr indent="0" marL="0">
+              <a:spcAft>
+                <a:spcPts val="600"/>
+              </a:spcAft>
+              <a:buNone/>
+            </a:pPr>
+            <a:r>
+              <a:rPr lang="en-US" sz="1500" dirty="0">
+                <a:solidFill>
+                  <a:srgbClr val="1A1A1A"/>
+                </a:solidFill>
+                <a:latin typeface="Calibri" pitchFamily="34" charset="0"/>
+                <a:ea typeface="Calibri" pitchFamily="34" charset="-122"/>
+                <a:cs typeface="Calibri" pitchFamily="34" charset="-120"/>
+              </a:rPr>
+              <a:t>Quantity: 50 → 45 per week  (−10%)</a:t>
+            </a:r>
+            <a:endParaRPr lang="en-US" sz="1500" dirty="0"/>
+          </a:p>
+        </p:txBody>
+      </p:sp>
+      <p:sp>
+        <p:nvSpPr>
+          <p:cNvPr id="8" name="Text 6"/>
+          <p:cNvSpPr/>
+          <p:nvPr/>
+        </p:nvSpPr>
+        <p:spPr>
+          <a:xfrm>
+            <a:off x="3840480" y="4206240"/>
+            <a:ext cx="4480560" cy="731520"/>
+          </a:xfrm>
+          <a:prstGeom prst="rect">
+            <a:avLst/>
+          </a:prstGeom>
+          <a:noFill/>
+          <a:ln/>
+        </p:spPr>
+        <p:txBody>
+          <a:bodyPr wrap="square" rtlCol="0" anchor="ctr"/>
+          <a:lstStyle/>
+          <a:p>
+            <a:pPr indent="0" marL="0">
+              <a:buNone/>
+            </a:pPr>
+            <a:r>
+              <a:rPr lang="en-US" sz="1800" b="1" dirty="0">
                 <a:solidFill>
                   <a:srgbClr val="1E2761"/>
                 </a:solidFill>
@@ -5376,109 +7190,9 @@
                 <a:ea typeface="Cambria" pitchFamily="34" charset="-122"/>
                 <a:cs typeface="Cambria" pitchFamily="34" charset="-120"/>
               </a:rPr>
-              <a:t>Total revenue</a:t>
-            </a:r>
-            <a:endParaRPr lang="en-US" sz="3000" dirty="0"/>
-          </a:p>
-        </p:txBody>
-      </p:sp>
-      <p:sp>
-        <p:nvSpPr>
-          <p:cNvPr id="3" name="Shape 1"/>
-          <p:cNvSpPr/>
-          <p:nvPr/>
-        </p:nvSpPr>
-        <p:spPr>
-          <a:xfrm>
-            <a:off x="2651760" y="1645920"/>
-            <a:ext cx="6858000" cy="1188720"/>
-          </a:xfrm>
-          <a:prstGeom prst="roundRect">
-            <a:avLst>
-              <a:gd name="adj" fmla="val 10769"/>
-            </a:avLst>
-          </a:prstGeom>
-          <a:solidFill>
-            <a:srgbClr val="1E2761"/>
-          </a:solidFill>
-          <a:ln/>
-        </p:spPr>
-      </p:sp>
-      <p:sp>
-        <p:nvSpPr>
-          <p:cNvPr id="4" name="Text 2"/>
-          <p:cNvSpPr/>
-          <p:nvPr/>
-        </p:nvSpPr>
-        <p:spPr>
-          <a:xfrm>
-            <a:off x="2651760" y="1645920"/>
-            <a:ext cx="6858000" cy="1188720"/>
-          </a:xfrm>
-          <a:prstGeom prst="rect">
-            <a:avLst/>
-          </a:prstGeom>
-          <a:noFill/>
-          <a:ln/>
-        </p:spPr>
-        <p:txBody>
-          <a:bodyPr wrap="square" rtlCol="0" anchor="ctr"/>
-          <a:lstStyle/>
-          <a:p>
-            <a:pPr algn="ctr" indent="0" marL="0">
-              <a:buNone/>
-            </a:pPr>
-            <a:r>
-              <a:rPr lang="en-US" sz="3000" b="1" dirty="0">
-                <a:solidFill>
-                  <a:srgbClr val="CADCFC"/>
-                </a:solidFill>
-                <a:latin typeface="Cambria" pitchFamily="34" charset="0"/>
-                <a:ea typeface="Cambria" pitchFamily="34" charset="-122"/>
-                <a:cs typeface="Cambria" pitchFamily="34" charset="-120"/>
-              </a:rPr>
-              <a:t>TR = P × Q</a:t>
-            </a:r>
-            <a:endParaRPr lang="en-US" sz="3000" dirty="0"/>
-          </a:p>
-        </p:txBody>
-      </p:sp>
-      <p:sp>
-        <p:nvSpPr>
-          <p:cNvPr id="5" name="Text 3"/>
-          <p:cNvSpPr/>
-          <p:nvPr/>
-        </p:nvSpPr>
-        <p:spPr>
-          <a:xfrm>
-            <a:off x="822960" y="3108960"/>
-            <a:ext cx="9601200" cy="914400"/>
-          </a:xfrm>
-          <a:prstGeom prst="rect">
-            <a:avLst/>
-          </a:prstGeom>
-          <a:noFill/>
-          <a:ln/>
-        </p:spPr>
-        <p:txBody>
-          <a:bodyPr wrap="square" rtlCol="0" anchor="ctr"/>
-          <a:lstStyle/>
-          <a:p>
-            <a:pPr indent="0" marL="0">
-              <a:buNone/>
-            </a:pPr>
-            <a:r>
-              <a:rPr lang="en-US" sz="1600" dirty="0">
-                <a:solidFill>
-                  <a:srgbClr val="1A1A1A"/>
-                </a:solidFill>
-                <a:latin typeface="Calibri" pitchFamily="34" charset="0"/>
-                <a:ea typeface="Calibri" pitchFamily="34" charset="-122"/>
-                <a:cs typeface="Calibri" pitchFamily="34" charset="-120"/>
-              </a:rPr>
-              <a:t>A price change moves P. But it also moves Q, because of PED. Those two moves can fight each other — that's the whole lesson.</a:t>
-            </a:r>
-            <a:endParaRPr lang="en-US" sz="1600" dirty="0"/>
+              <a:t>PED = −10 ÷ 20 = −0.5 → Inelastic</a:t>
+            </a:r>
+            <a:endParaRPr lang="en-US" sz="1800" dirty="0"/>
           </a:p>
         </p:txBody>
       </p:sp>
@@ -5523,7 +7237,7 @@
         <p:spPr>
           <a:xfrm>
             <a:off x="640080" y="502920"/>
-            <a:ext cx="1728216" cy="365760"/>
+            <a:ext cx="1426464" cy="365760"/>
           </a:xfrm>
           <a:prstGeom prst="roundRect">
             <a:avLst>
@@ -5547,7 +7261,7 @@
         <p:spPr>
           <a:xfrm>
             <a:off x="640080" y="502920"/>
-            <a:ext cx="1728216" cy="365760"/>
+            <a:ext cx="1426464" cy="365760"/>
           </a:xfrm>
           <a:prstGeom prst="rect">
             <a:avLst/>
@@ -5571,7 +7285,7 @@
                 <a:ea typeface="Calibri" pitchFamily="34" charset="-122"/>
                 <a:cs typeface="Calibri" pitchFamily="34" charset="-120"/>
               </a:rPr>
-              <a:t>🤔 Guess first</a:t>
+              <a:t>✍️ Practice</a:t>
             </a:r>
             <a:endParaRPr lang="en-US" sz="1200" dirty="0"/>
           </a:p>
@@ -5610,7 +7324,7 @@
                 <a:ea typeface="Calibri" pitchFamily="34" charset="-122"/>
                 <a:cs typeface="Calibri" pitchFamily="34" charset="-120"/>
               </a:rPr>
-              <a:t>🎾 Padel bookings (elastic)</a:t>
+              <a:t>🏓 Limited-edition padel paddle</a:t>
             </a:r>
             <a:endParaRPr lang="en-US" sz="2200" dirty="0"/>
           </a:p>
@@ -5671,7 +7385,7 @@
                 <a:ea typeface="Calibri" pitchFamily="34" charset="-122"/>
                 <a:cs typeface="Calibri" pitchFamily="34" charset="-120"/>
               </a:rPr>
-              <a:t>Guess before you check</a:t>
+              <a:t>Practice: calculate the PED</a:t>
             </a:r>
             <a:endParaRPr lang="en-US" sz="1400" dirty="0"/>
           </a:p>
@@ -5713,7 +7427,7 @@
                 <a:ea typeface="Calibri" pitchFamily="34" charset="-122"/>
                 <a:cs typeface="Calibri" pitchFamily="34" charset="-120"/>
               </a:rPr>
-              <a:t>Price: $20 → $22  (+10%)</a:t>
+              <a:t>Price: $150 → $165  (+10%)</a:t>
             </a:r>
             <a:endParaRPr lang="en-US" sz="1500" dirty="0"/>
           </a:p>
@@ -5733,27 +7447,7 @@
                 <a:ea typeface="Calibri" pitchFamily="34" charset="-122"/>
                 <a:cs typeface="Calibri" pitchFamily="34" charset="-120"/>
               </a:rPr>
-              <a:t>Quantity: 100 → 80 bookings/week  (−20%)</a:t>
-            </a:r>
-            <a:endParaRPr lang="en-US" sz="1500" dirty="0"/>
-          </a:p>
-          <a:p>
-            <a:pPr indent="0" marL="0">
-              <a:spcAft>
-                <a:spcPts val="600"/>
-              </a:spcAft>
-              <a:buNone/>
-            </a:pPr>
-            <a:r>
-              <a:rPr lang="en-US" sz="1500" dirty="0">
-                <a:solidFill>
-                  <a:srgbClr val="1A1A1A"/>
-                </a:solidFill>
-                <a:latin typeface="Calibri" pitchFamily="34" charset="0"/>
-                <a:ea typeface="Calibri" pitchFamily="34" charset="-122"/>
-                <a:cs typeface="Calibri" pitchFamily="34" charset="-120"/>
-              </a:rPr>
-              <a:t>PED = −2 (elastic)</a:t>
+              <a:t>Quantity: 20 → 18 sold  (−10%)</a:t>
             </a:r>
             <a:endParaRPr lang="en-US" sz="1500" dirty="0"/>
           </a:p>
@@ -5792,7 +7486,7 @@
                 <a:ea typeface="Cambria" pitchFamily="34" charset="-122"/>
                 <a:cs typeface="Cambria" pitchFamily="34" charset="-120"/>
               </a:rPr>
-              <a:t>Revenue: up, down, or the same?</a:t>
+              <a:t>PED = −10 ÷ 10 = −1 → Unitary</a:t>
             </a:r>
             <a:endParaRPr lang="en-US" sz="1800" dirty="0"/>
           </a:p>
@@ -5839,7 +7533,7 @@
         <p:spPr>
           <a:xfrm>
             <a:off x="640080" y="502920"/>
-            <a:ext cx="1325880" cy="365760"/>
+            <a:ext cx="1426464" cy="365760"/>
           </a:xfrm>
           <a:prstGeom prst="roundRect">
             <a:avLst>
@@ -5847,7 +7541,7 @@
             </a:avLst>
           </a:prstGeom>
           <a:solidFill>
-            <a:srgbClr val="1BAF7A">
+            <a:srgbClr val="F96167">
               <a:alpha val="18000"/>
             </a:srgbClr>
           </a:solidFill>
@@ -5863,7 +7557,7 @@
         <p:spPr>
           <a:xfrm>
             <a:off x="640080" y="502920"/>
-            <a:ext cx="1325880" cy="365760"/>
+            <a:ext cx="1426464" cy="365760"/>
           </a:xfrm>
           <a:prstGeom prst="rect">
             <a:avLst/>
@@ -5881,13 +7575,13 @@
             <a:r>
               <a:rPr lang="en-US" sz="1200" b="1" dirty="0">
                 <a:solidFill>
-                  <a:srgbClr val="1BAF7A"/>
+                  <a:srgbClr val="F96167"/>
                 </a:solidFill>
                 <a:latin typeface="Calibri" pitchFamily="34" charset="0"/>
                 <a:ea typeface="Calibri" pitchFamily="34" charset="-122"/>
                 <a:cs typeface="Calibri" pitchFamily="34" charset="-120"/>
               </a:rPr>
-              <a:t>✅ Revealed</a:t>
+              <a:t>✍️ Practice</a:t>
             </a:r>
             <a:endParaRPr lang="en-US" sz="1200" dirty="0"/>
           </a:p>
@@ -5926,7 +7620,7 @@
                 <a:ea typeface="Calibri" pitchFamily="34" charset="-122"/>
                 <a:cs typeface="Calibri" pitchFamily="34" charset="-120"/>
               </a:rPr>
-              <a:t>🎾 Padel bookings — answer</a:t>
+              <a:t>🧱 Generic Lego minifigure</a:t>
             </a:r>
             <a:endParaRPr lang="en-US" sz="2200" dirty="0"/>
           </a:p>
@@ -5987,7 +7681,7 @@
                 <a:ea typeface="Calibri" pitchFamily="34" charset="-122"/>
                 <a:cs typeface="Calibri" pitchFamily="34" charset="-120"/>
               </a:rPr>
-              <a:t>The reveal</a:t>
+              <a:t>Practice: calculate the PED</a:t>
             </a:r>
             <a:endParaRPr lang="en-US" sz="1400" dirty="0"/>
           </a:p>
@@ -6029,7 +7723,7 @@
                 <a:ea typeface="Calibri" pitchFamily="34" charset="-122"/>
                 <a:cs typeface="Calibri" pitchFamily="34" charset="-120"/>
               </a:rPr>
-              <a:t>TR before = $20 × 100 = $2000</a:t>
+              <a:t>Price: $5 → $6  (+20%)</a:t>
             </a:r>
             <a:endParaRPr lang="en-US" sz="1500" dirty="0"/>
           </a:p>
@@ -6049,7 +7743,7 @@
                 <a:ea typeface="Calibri" pitchFamily="34" charset="-122"/>
                 <a:cs typeface="Calibri" pitchFamily="34" charset="-120"/>
               </a:rPr>
-              <a:t>TR after = $22 × 80 = $1760</a:t>
+              <a:t>Quantity: 100 → 70 sold  (−30%)</a:t>
             </a:r>
             <a:endParaRPr lang="en-US" sz="1500" dirty="0"/>
           </a:p>
@@ -6082,13 +7776,13 @@
             <a:r>
               <a:rPr lang="en-US" sz="1800" b="1" dirty="0">
                 <a:solidFill>
-                  <a:srgbClr val="1BAF7A"/>
+                  <a:srgbClr val="1E2761"/>
                 </a:solidFill>
                 <a:latin typeface="Cambria" pitchFamily="34" charset="0"/>
                 <a:ea typeface="Cambria" pitchFamily="34" charset="-122"/>
                 <a:cs typeface="Cambria" pitchFamily="34" charset="-120"/>
               </a:rPr>
-              <a:t>Revenue FELL, despite the price rise</a:t>
+              <a:t>PED = −30 ÷ 20 = −1.5 → Elastic</a:t>
             </a:r>
             <a:endParaRPr lang="en-US" sz="1800" dirty="0"/>
           </a:p>
@@ -6128,27 +7822,42 @@
       </p:grpSpPr>
       <p:sp>
         <p:nvSpPr>
-          <p:cNvPr id="2" name="Shape 0"/>
-          <p:cNvSpPr/>
-          <p:nvPr/>
-        </p:nvSpPr>
-        <p:spPr>
-          <a:xfrm>
-            <a:off x="640080" y="502920"/>
-            <a:ext cx="1728216" cy="365760"/>
-          </a:xfrm>
-          <a:prstGeom prst="roundRect">
-            <a:avLst>
-              <a:gd name="adj" fmla="val 50000"/>
-            </a:avLst>
-          </a:prstGeom>
-          <a:solidFill>
-            <a:srgbClr val="F96167">
-              <a:alpha val="18000"/>
-            </a:srgbClr>
-          </a:solidFill>
-          <a:ln/>
-        </p:spPr>
+          <p:cNvPr id="2" name="Text 0"/>
+          <p:cNvSpPr/>
+          <p:nvPr/>
+        </p:nvSpPr>
+        <p:spPr>
+          <a:xfrm>
+            <a:off x="640080" y="548640"/>
+            <a:ext cx="10881360" cy="822960"/>
+          </a:xfrm>
+          <a:prstGeom prst="rect">
+            <a:avLst/>
+          </a:prstGeom>
+          <a:noFill/>
+          <a:ln/>
+        </p:spPr>
+        <p:txBody>
+          <a:bodyPr wrap="square" rtlCol="0" anchor="ctr"/>
+          <a:lstStyle/>
+          <a:p>
+            <a:pPr indent="0" marL="0">
+              <a:buNone/>
+            </a:pPr>
+            <a:r>
+              <a:rPr lang="en-US" sz="3200" b="1" dirty="0">
+                <a:solidFill>
+                  <a:srgbClr val="1E2761"/>
+                </a:solidFill>
+                <a:latin typeface="Cambria" pitchFamily="34" charset="0"/>
+                <a:ea typeface="Cambria" pitchFamily="34" charset="-122"/>
+                <a:cs typeface="Cambria" pitchFamily="34" charset="-120"/>
+              </a:rPr>
+              <a:t>Today's real question</a:t>
+            </a:r>
+            <a:endParaRPr lang="en-US" sz="3200" dirty="0"/>
+          </a:p>
+        </p:txBody>
       </p:sp>
       <p:sp>
         <p:nvSpPr>
@@ -6158,8 +7867,8 @@
         </p:nvSpPr>
         <p:spPr>
           <a:xfrm>
-            <a:off x="640080" y="502920"/>
-            <a:ext cx="1728216" cy="365760"/>
+            <a:off x="822960" y="1828800"/>
+            <a:ext cx="9875520" cy="4114800"/>
           </a:xfrm>
           <a:prstGeom prst="rect">
             <a:avLst/>
@@ -6168,243 +7877,74 @@
           <a:ln/>
         </p:spPr>
         <p:txBody>
-          <a:bodyPr wrap="square" rtlCol="0" anchor="ctr"/>
-          <a:lstStyle/>
-          <a:p>
-            <a:pPr algn="ctr" indent="0" marL="0">
-              <a:buNone/>
-            </a:pPr>
-            <a:r>
-              <a:rPr lang="en-US" sz="1200" b="1" dirty="0">
-                <a:solidFill>
-                  <a:srgbClr val="F96167"/>
+          <a:bodyPr wrap="square" rtlCol="0" anchor="t"/>
+          <a:lstStyle/>
+          <a:p>
+            <a:pPr indent="0" marL="0">
+              <a:lnSpc>
+                <a:spcPct val="130000"/>
+              </a:lnSpc>
+              <a:spcAft>
+                <a:spcPts val="1400"/>
+              </a:spcAft>
+              <a:buNone/>
+            </a:pPr>
+            <a:r>
+              <a:rPr lang="en-US" sz="1800" dirty="0">
+                <a:solidFill>
+                  <a:srgbClr val="1A1A1A"/>
                 </a:solidFill>
                 <a:latin typeface="Calibri" pitchFamily="34" charset="0"/>
                 <a:ea typeface="Calibri" pitchFamily="34" charset="-122"/>
                 <a:cs typeface="Calibri" pitchFamily="34" charset="-120"/>
               </a:rPr>
-              <a:t>🤔 Guess first</a:t>
-            </a:r>
-            <a:endParaRPr lang="en-US" sz="1200" dirty="0"/>
-          </a:p>
-        </p:txBody>
-      </p:sp>
-      <p:sp>
-        <p:nvSpPr>
-          <p:cNvPr id="4" name="Text 2"/>
-          <p:cNvSpPr/>
-          <p:nvPr/>
-        </p:nvSpPr>
-        <p:spPr>
-          <a:xfrm>
-            <a:off x="640080" y="1051560"/>
-            <a:ext cx="10881360" cy="548640"/>
-          </a:xfrm>
-          <a:prstGeom prst="rect">
-            <a:avLst/>
-          </a:prstGeom>
-          <a:noFill/>
-          <a:ln/>
-        </p:spPr>
-        <p:txBody>
-          <a:bodyPr wrap="square" rtlCol="0" anchor="ctr"/>
-          <a:lstStyle/>
+              <a:t>Tom puts up the price of his padel grips.</a:t>
+            </a:r>
+            <a:endParaRPr lang="en-US" sz="1800" dirty="0"/>
+          </a:p>
           <a:p>
             <a:pPr indent="0" marL="0">
-              <a:buNone/>
-            </a:pPr>
-            <a:r>
-              <a:rPr lang="en-US" sz="2200" b="1" dirty="0">
-                <a:solidFill>
-                  <a:srgbClr val="1E2761"/>
+              <a:lnSpc>
+                <a:spcPct val="130000"/>
+              </a:lnSpc>
+              <a:spcAft>
+                <a:spcPts val="1400"/>
+              </a:spcAft>
+              <a:buNone/>
+            </a:pPr>
+            <a:r>
+              <a:rPr lang="en-US" sz="1800" dirty="0">
+                <a:solidFill>
+                  <a:srgbClr val="1A1A1A"/>
                 </a:solidFill>
                 <a:latin typeface="Calibri" pitchFamily="34" charset="0"/>
                 <a:ea typeface="Calibri" pitchFamily="34" charset="-122"/>
                 <a:cs typeface="Calibri" pitchFamily="34" charset="-120"/>
               </a:rPr>
-              <a:t>🧩 Retired Lego set (inelastic)</a:t>
-            </a:r>
-            <a:endParaRPr lang="en-US" sz="2200" dirty="0"/>
-          </a:p>
-        </p:txBody>
-      </p:sp>
-      <p:sp>
-        <p:nvSpPr>
-          <p:cNvPr id="5" name="Shape 3"/>
-          <p:cNvSpPr/>
-          <p:nvPr/>
-        </p:nvSpPr>
-        <p:spPr>
-          <a:xfrm>
-            <a:off x="3566160" y="1920240"/>
-            <a:ext cx="5029200" cy="3108960"/>
-          </a:xfrm>
-          <a:prstGeom prst="roundRect">
-            <a:avLst>
-              <a:gd name="adj" fmla="val 4118"/>
-            </a:avLst>
-          </a:prstGeom>
-          <a:solidFill>
-            <a:srgbClr val="F4F5F7"/>
-          </a:solidFill>
-          <a:ln/>
-        </p:spPr>
-      </p:sp>
-      <p:sp>
-        <p:nvSpPr>
-          <p:cNvPr id="6" name="Text 4"/>
-          <p:cNvSpPr/>
-          <p:nvPr/>
-        </p:nvSpPr>
-        <p:spPr>
-          <a:xfrm>
-            <a:off x="3840480" y="2194560"/>
-            <a:ext cx="4480560" cy="365760"/>
-          </a:xfrm>
-          <a:prstGeom prst="rect">
-            <a:avLst/>
-          </a:prstGeom>
-          <a:noFill/>
-          <a:ln/>
-        </p:spPr>
-        <p:txBody>
-          <a:bodyPr wrap="square" rtlCol="0" anchor="ctr"/>
-          <a:lstStyle/>
+              <a:t>More money per grip sold... but does he end up with more total money?</a:t>
+            </a:r>
+            <a:endParaRPr lang="en-US" sz="1800" dirty="0"/>
+          </a:p>
           <a:p>
             <a:pPr indent="0" marL="0">
-              <a:buNone/>
-            </a:pPr>
-            <a:r>
-              <a:rPr lang="en-US" sz="1400" b="1" dirty="0">
-                <a:solidFill>
-                  <a:srgbClr val="5B5B5B"/>
+              <a:lnSpc>
+                <a:spcPct val="130000"/>
+              </a:lnSpc>
+              <a:spcAft>
+                <a:spcPts val="1400"/>
+              </a:spcAft>
+              <a:buNone/>
+            </a:pPr>
+            <a:r>
+              <a:rPr lang="en-US" sz="1800" dirty="0">
+                <a:solidFill>
+                  <a:srgbClr val="1A1A1A"/>
                 </a:solidFill>
                 <a:latin typeface="Calibri" pitchFamily="34" charset="0"/>
                 <a:ea typeface="Calibri" pitchFamily="34" charset="-122"/>
                 <a:cs typeface="Calibri" pitchFamily="34" charset="-120"/>
               </a:rPr>
-              <a:t>Guess before you check</a:t>
-            </a:r>
-            <a:endParaRPr lang="en-US" sz="1400" dirty="0"/>
-          </a:p>
-        </p:txBody>
-      </p:sp>
-      <p:sp>
-        <p:nvSpPr>
-          <p:cNvPr id="7" name="Text 5"/>
-          <p:cNvSpPr/>
-          <p:nvPr/>
-        </p:nvSpPr>
-        <p:spPr>
-          <a:xfrm>
-            <a:off x="3840480" y="2651760"/>
-            <a:ext cx="4480560" cy="1463040"/>
-          </a:xfrm>
-          <a:prstGeom prst="rect">
-            <a:avLst/>
-          </a:prstGeom>
-          <a:noFill/>
-          <a:ln/>
-        </p:spPr>
-        <p:txBody>
-          <a:bodyPr wrap="square" rtlCol="0" anchor="t"/>
-          <a:lstStyle/>
-          <a:p>
-            <a:pPr indent="0" marL="0">
-              <a:spcAft>
-                <a:spcPts val="600"/>
-              </a:spcAft>
-              <a:buNone/>
-            </a:pPr>
-            <a:r>
-              <a:rPr lang="en-US" sz="1500" dirty="0">
-                <a:solidFill>
-                  <a:srgbClr val="1A1A1A"/>
-                </a:solidFill>
-                <a:latin typeface="Calibri" pitchFamily="34" charset="0"/>
-                <a:ea typeface="Calibri" pitchFamily="34" charset="-122"/>
-                <a:cs typeface="Calibri" pitchFamily="34" charset="-120"/>
-              </a:rPr>
-              <a:t>Price: $50 → $55  (+10%)</a:t>
-            </a:r>
-            <a:endParaRPr lang="en-US" sz="1500" dirty="0"/>
-          </a:p>
-          <a:p>
-            <a:pPr indent="0" marL="0">
-              <a:spcAft>
-                <a:spcPts val="600"/>
-              </a:spcAft>
-              <a:buNone/>
-            </a:pPr>
-            <a:r>
-              <a:rPr lang="en-US" sz="1500" dirty="0">
-                <a:solidFill>
-                  <a:srgbClr val="1A1A1A"/>
-                </a:solidFill>
-                <a:latin typeface="Calibri" pitchFamily="34" charset="0"/>
-                <a:ea typeface="Calibri" pitchFamily="34" charset="-122"/>
-                <a:cs typeface="Calibri" pitchFamily="34" charset="-120"/>
-              </a:rPr>
-              <a:t>Quantity: 40 → 38 sets/month  (−5%)</a:t>
-            </a:r>
-            <a:endParaRPr lang="en-US" sz="1500" dirty="0"/>
-          </a:p>
-          <a:p>
-            <a:pPr indent="0" marL="0">
-              <a:spcAft>
-                <a:spcPts val="600"/>
-              </a:spcAft>
-              <a:buNone/>
-            </a:pPr>
-            <a:r>
-              <a:rPr lang="en-US" sz="1500" dirty="0">
-                <a:solidFill>
-                  <a:srgbClr val="1A1A1A"/>
-                </a:solidFill>
-                <a:latin typeface="Calibri" pitchFamily="34" charset="0"/>
-                <a:ea typeface="Calibri" pitchFamily="34" charset="-122"/>
-                <a:cs typeface="Calibri" pitchFamily="34" charset="-120"/>
-              </a:rPr>
-              <a:t>PED = −0.5 (inelastic)</a:t>
-            </a:r>
-            <a:endParaRPr lang="en-US" sz="1500" dirty="0"/>
-          </a:p>
-        </p:txBody>
-      </p:sp>
-      <p:sp>
-        <p:nvSpPr>
-          <p:cNvPr id="8" name="Text 6"/>
-          <p:cNvSpPr/>
-          <p:nvPr/>
-        </p:nvSpPr>
-        <p:spPr>
-          <a:xfrm>
-            <a:off x="3840480" y="4206240"/>
-            <a:ext cx="4480560" cy="731520"/>
-          </a:xfrm>
-          <a:prstGeom prst="rect">
-            <a:avLst/>
-          </a:prstGeom>
-          <a:noFill/>
-          <a:ln/>
-        </p:spPr>
-        <p:txBody>
-          <a:bodyPr wrap="square" rtlCol="0" anchor="ctr"/>
-          <a:lstStyle/>
-          <a:p>
-            <a:pPr indent="0" marL="0">
-              <a:buNone/>
-            </a:pPr>
-            <a:r>
-              <a:rPr lang="en-US" sz="1800" b="1" dirty="0">
-                <a:solidFill>
-                  <a:srgbClr val="1E2761"/>
-                </a:solidFill>
-                <a:latin typeface="Cambria" pitchFamily="34" charset="0"/>
-                <a:ea typeface="Cambria" pitchFamily="34" charset="-122"/>
-                <a:cs typeface="Cambria" pitchFamily="34" charset="-120"/>
-              </a:rPr>
-              <a:t>Revenue: up, down, or the same?</a:t>
+              <a:t>Guess — and tell me why.</a:t>
             </a:r>
             <a:endParaRPr lang="en-US" sz="1800" dirty="0"/>
           </a:p>
@@ -6444,38 +7984,75 @@
       </p:grpSpPr>
       <p:sp>
         <p:nvSpPr>
-          <p:cNvPr id="2" name="Shape 0"/>
-          <p:cNvSpPr/>
-          <p:nvPr/>
-        </p:nvSpPr>
-        <p:spPr>
-          <a:xfrm>
-            <a:off x="640080" y="502920"/>
-            <a:ext cx="1325880" cy="365760"/>
+          <p:cNvPr id="2" name="Text 0"/>
+          <p:cNvSpPr/>
+          <p:nvPr/>
+        </p:nvSpPr>
+        <p:spPr>
+          <a:xfrm>
+            <a:off x="640080" y="640080"/>
+            <a:ext cx="10881360" cy="731520"/>
+          </a:xfrm>
+          <a:prstGeom prst="rect">
+            <a:avLst/>
+          </a:prstGeom>
+          <a:noFill/>
+          <a:ln/>
+        </p:spPr>
+        <p:txBody>
+          <a:bodyPr wrap="square" rtlCol="0" anchor="ctr"/>
+          <a:lstStyle/>
+          <a:p>
+            <a:pPr indent="0" marL="0">
+              <a:buNone/>
+            </a:pPr>
+            <a:r>
+              <a:rPr lang="en-US" sz="3000" b="1" dirty="0">
+                <a:solidFill>
+                  <a:srgbClr val="1E2761"/>
+                </a:solidFill>
+                <a:latin typeface="Cambria" pitchFamily="34" charset="0"/>
+                <a:ea typeface="Cambria" pitchFamily="34" charset="-122"/>
+                <a:cs typeface="Cambria" pitchFamily="34" charset="-120"/>
+              </a:rPr>
+              <a:t>Total revenue</a:t>
+            </a:r>
+            <a:endParaRPr lang="en-US" sz="3000" dirty="0"/>
+          </a:p>
+        </p:txBody>
+      </p:sp>
+      <p:sp>
+        <p:nvSpPr>
+          <p:cNvPr id="3" name="Shape 1"/>
+          <p:cNvSpPr/>
+          <p:nvPr/>
+        </p:nvSpPr>
+        <p:spPr>
+          <a:xfrm>
+            <a:off x="2651760" y="1645920"/>
+            <a:ext cx="6858000" cy="1188720"/>
           </a:xfrm>
           <a:prstGeom prst="roundRect">
             <a:avLst>
-              <a:gd name="adj" fmla="val 50000"/>
+              <a:gd name="adj" fmla="val 10769"/>
             </a:avLst>
           </a:prstGeom>
           <a:solidFill>
-            <a:srgbClr val="1BAF7A">
-              <a:alpha val="18000"/>
-            </a:srgbClr>
+            <a:srgbClr val="1E2761"/>
           </a:solidFill>
           <a:ln/>
         </p:spPr>
       </p:sp>
       <p:sp>
         <p:nvSpPr>
-          <p:cNvPr id="3" name="Text 1"/>
-          <p:cNvSpPr/>
-          <p:nvPr/>
-        </p:nvSpPr>
-        <p:spPr>
-          <a:xfrm>
-            <a:off x="640080" y="502920"/>
-            <a:ext cx="1325880" cy="365760"/>
+          <p:cNvPr id="4" name="Text 2"/>
+          <p:cNvSpPr/>
+          <p:nvPr/>
+        </p:nvSpPr>
+        <p:spPr>
+          <a:xfrm>
+            <a:off x="2651760" y="1645920"/>
+            <a:ext cx="6858000" cy="1188720"/>
           </a:xfrm>
           <a:prstGeom prst="rect">
             <a:avLst/>
@@ -6491,218 +8068,56 @@
               <a:buNone/>
             </a:pPr>
             <a:r>
-              <a:rPr lang="en-US" sz="1200" b="1" dirty="0">
-                <a:solidFill>
-                  <a:srgbClr val="1BAF7A"/>
+              <a:rPr lang="en-US" sz="3000" b="1" dirty="0">
+                <a:solidFill>
+                  <a:srgbClr val="CADCFC"/>
+                </a:solidFill>
+                <a:latin typeface="Cambria" pitchFamily="34" charset="0"/>
+                <a:ea typeface="Cambria" pitchFamily="34" charset="-122"/>
+                <a:cs typeface="Cambria" pitchFamily="34" charset="-120"/>
+              </a:rPr>
+              <a:t>TR = P × Q</a:t>
+            </a:r>
+            <a:endParaRPr lang="en-US" sz="3000" dirty="0"/>
+          </a:p>
+        </p:txBody>
+      </p:sp>
+      <p:sp>
+        <p:nvSpPr>
+          <p:cNvPr id="5" name="Text 3"/>
+          <p:cNvSpPr/>
+          <p:nvPr/>
+        </p:nvSpPr>
+        <p:spPr>
+          <a:xfrm>
+            <a:off x="822960" y="3108960"/>
+            <a:ext cx="9601200" cy="914400"/>
+          </a:xfrm>
+          <a:prstGeom prst="rect">
+            <a:avLst/>
+          </a:prstGeom>
+          <a:noFill/>
+          <a:ln/>
+        </p:spPr>
+        <p:txBody>
+          <a:bodyPr wrap="square" rtlCol="0" anchor="ctr"/>
+          <a:lstStyle/>
+          <a:p>
+            <a:pPr indent="0" marL="0">
+              <a:buNone/>
+            </a:pPr>
+            <a:r>
+              <a:rPr lang="en-US" sz="1600" dirty="0">
+                <a:solidFill>
+                  <a:srgbClr val="1A1A1A"/>
                 </a:solidFill>
                 <a:latin typeface="Calibri" pitchFamily="34" charset="0"/>
                 <a:ea typeface="Calibri" pitchFamily="34" charset="-122"/>
                 <a:cs typeface="Calibri" pitchFamily="34" charset="-120"/>
               </a:rPr>
-              <a:t>✅ Revealed</a:t>
-            </a:r>
-            <a:endParaRPr lang="en-US" sz="1200" dirty="0"/>
-          </a:p>
-        </p:txBody>
-      </p:sp>
-      <p:sp>
-        <p:nvSpPr>
-          <p:cNvPr id="4" name="Text 2"/>
-          <p:cNvSpPr/>
-          <p:nvPr/>
-        </p:nvSpPr>
-        <p:spPr>
-          <a:xfrm>
-            <a:off x="640080" y="1051560"/>
-            <a:ext cx="10881360" cy="548640"/>
-          </a:xfrm>
-          <a:prstGeom prst="rect">
-            <a:avLst/>
-          </a:prstGeom>
-          <a:noFill/>
-          <a:ln/>
-        </p:spPr>
-        <p:txBody>
-          <a:bodyPr wrap="square" rtlCol="0" anchor="ctr"/>
-          <a:lstStyle/>
-          <a:p>
-            <a:pPr indent="0" marL="0">
-              <a:buNone/>
-            </a:pPr>
-            <a:r>
-              <a:rPr lang="en-US" sz="2200" b="1" dirty="0">
-                <a:solidFill>
-                  <a:srgbClr val="1E2761"/>
-                </a:solidFill>
-                <a:latin typeface="Calibri" pitchFamily="34" charset="0"/>
-                <a:ea typeface="Calibri" pitchFamily="34" charset="-122"/>
-                <a:cs typeface="Calibri" pitchFamily="34" charset="-120"/>
-              </a:rPr>
-              <a:t>🧩 Retired Lego set — answer</a:t>
-            </a:r>
-            <a:endParaRPr lang="en-US" sz="2200" dirty="0"/>
-          </a:p>
-        </p:txBody>
-      </p:sp>
-      <p:sp>
-        <p:nvSpPr>
-          <p:cNvPr id="5" name="Shape 3"/>
-          <p:cNvSpPr/>
-          <p:nvPr/>
-        </p:nvSpPr>
-        <p:spPr>
-          <a:xfrm>
-            <a:off x="3566160" y="1920240"/>
-            <a:ext cx="5029200" cy="3108960"/>
-          </a:xfrm>
-          <a:prstGeom prst="roundRect">
-            <a:avLst>
-              <a:gd name="adj" fmla="val 4118"/>
-            </a:avLst>
-          </a:prstGeom>
-          <a:solidFill>
-            <a:srgbClr val="F4F5F7"/>
-          </a:solidFill>
-          <a:ln/>
-        </p:spPr>
-      </p:sp>
-      <p:sp>
-        <p:nvSpPr>
-          <p:cNvPr id="6" name="Text 4"/>
-          <p:cNvSpPr/>
-          <p:nvPr/>
-        </p:nvSpPr>
-        <p:spPr>
-          <a:xfrm>
-            <a:off x="3840480" y="2194560"/>
-            <a:ext cx="4480560" cy="365760"/>
-          </a:xfrm>
-          <a:prstGeom prst="rect">
-            <a:avLst/>
-          </a:prstGeom>
-          <a:noFill/>
-          <a:ln/>
-        </p:spPr>
-        <p:txBody>
-          <a:bodyPr wrap="square" rtlCol="0" anchor="ctr"/>
-          <a:lstStyle/>
-          <a:p>
-            <a:pPr indent="0" marL="0">
-              <a:buNone/>
-            </a:pPr>
-            <a:r>
-              <a:rPr lang="en-US" sz="1400" b="1" dirty="0">
-                <a:solidFill>
-                  <a:srgbClr val="5B5B5B"/>
-                </a:solidFill>
-                <a:latin typeface="Calibri" pitchFamily="34" charset="0"/>
-                <a:ea typeface="Calibri" pitchFamily="34" charset="-122"/>
-                <a:cs typeface="Calibri" pitchFamily="34" charset="-120"/>
-              </a:rPr>
-              <a:t>The reveal</a:t>
-            </a:r>
-            <a:endParaRPr lang="en-US" sz="1400" dirty="0"/>
-          </a:p>
-        </p:txBody>
-      </p:sp>
-      <p:sp>
-        <p:nvSpPr>
-          <p:cNvPr id="7" name="Text 5"/>
-          <p:cNvSpPr/>
-          <p:nvPr/>
-        </p:nvSpPr>
-        <p:spPr>
-          <a:xfrm>
-            <a:off x="3840480" y="2651760"/>
-            <a:ext cx="4480560" cy="1463040"/>
-          </a:xfrm>
-          <a:prstGeom prst="rect">
-            <a:avLst/>
-          </a:prstGeom>
-          <a:noFill/>
-          <a:ln/>
-        </p:spPr>
-        <p:txBody>
-          <a:bodyPr wrap="square" rtlCol="0" anchor="t"/>
-          <a:lstStyle/>
-          <a:p>
-            <a:pPr indent="0" marL="0">
-              <a:spcAft>
-                <a:spcPts val="600"/>
-              </a:spcAft>
-              <a:buNone/>
-            </a:pPr>
-            <a:r>
-              <a:rPr lang="en-US" sz="1500" dirty="0">
-                <a:solidFill>
-                  <a:srgbClr val="1A1A1A"/>
-                </a:solidFill>
-                <a:latin typeface="Calibri" pitchFamily="34" charset="0"/>
-                <a:ea typeface="Calibri" pitchFamily="34" charset="-122"/>
-                <a:cs typeface="Calibri" pitchFamily="34" charset="-120"/>
-              </a:rPr>
-              <a:t>TR before = $50 × 40 = $2000</a:t>
-            </a:r>
-            <a:endParaRPr lang="en-US" sz="1500" dirty="0"/>
-          </a:p>
-          <a:p>
-            <a:pPr indent="0" marL="0">
-              <a:spcAft>
-                <a:spcPts val="600"/>
-              </a:spcAft>
-              <a:buNone/>
-            </a:pPr>
-            <a:r>
-              <a:rPr lang="en-US" sz="1500" dirty="0">
-                <a:solidFill>
-                  <a:srgbClr val="1A1A1A"/>
-                </a:solidFill>
-                <a:latin typeface="Calibri" pitchFamily="34" charset="0"/>
-                <a:ea typeface="Calibri" pitchFamily="34" charset="-122"/>
-                <a:cs typeface="Calibri" pitchFamily="34" charset="-120"/>
-              </a:rPr>
-              <a:t>TR after = $55 × 38 = $2090</a:t>
-            </a:r>
-            <a:endParaRPr lang="en-US" sz="1500" dirty="0"/>
-          </a:p>
-        </p:txBody>
-      </p:sp>
-      <p:sp>
-        <p:nvSpPr>
-          <p:cNvPr id="8" name="Text 6"/>
-          <p:cNvSpPr/>
-          <p:nvPr/>
-        </p:nvSpPr>
-        <p:spPr>
-          <a:xfrm>
-            <a:off x="3840480" y="4206240"/>
-            <a:ext cx="4480560" cy="731520"/>
-          </a:xfrm>
-          <a:prstGeom prst="rect">
-            <a:avLst/>
-          </a:prstGeom>
-          <a:noFill/>
-          <a:ln/>
-        </p:spPr>
-        <p:txBody>
-          <a:bodyPr wrap="square" rtlCol="0" anchor="ctr"/>
-          <a:lstStyle/>
-          <a:p>
-            <a:pPr indent="0" marL="0">
-              <a:buNone/>
-            </a:pPr>
-            <a:r>
-              <a:rPr lang="en-US" sz="1800" b="1" dirty="0">
-                <a:solidFill>
-                  <a:srgbClr val="1BAF7A"/>
-                </a:solidFill>
-                <a:latin typeface="Cambria" pitchFamily="34" charset="0"/>
-                <a:ea typeface="Cambria" pitchFamily="34" charset="-122"/>
-                <a:cs typeface="Cambria" pitchFamily="34" charset="-120"/>
-              </a:rPr>
-              <a:t>Revenue ROSE this time</a:t>
-            </a:r>
-            <a:endParaRPr lang="en-US" sz="1800" dirty="0"/>
+              <a:t>A price change moves P. But it also moves Q, because of PED. Those two moves can fight each other — that's the whole lesson.</a:t>
+            </a:r>
+            <a:endParaRPr lang="en-US" sz="1600" dirty="0"/>
           </a:p>
         </p:txBody>
       </p:sp>

</xml_diff>